<commit_message>
Expand simulator guide with actual input and result screenshots
</commit_message>
<xml_diff>
--- a/docs/presentations/pharma-cost-simulator-guide.pptx
+++ b/docs/presentations/pharma-cost-simulator-guide.pptx
@@ -7,6 +7,9 @@
   <p:sldIdLst>
     <p:sldId id="256" r:id="rId7"/>
     <p:sldId id="257" r:id="rId9"/>
+    <p:sldId id="258" r:id="rId10"/>
+    <p:sldId id="259" r:id="rId11"/>
+    <p:sldId id="260" r:id="rId12"/>
   </p:sldIdLst>
   <p:sldSz cx="12191999" cy="6858000" type="screen4x3"/>
   <p:notesSz cx="6858000" cy="9144000"/>
@@ -503,7 +506,7 @@
           <a:lstStyle/>
           <a:p>
             <a:r>
-              <a:t>현재 웹 버전(2026-10-23) 소개입니다. 결과 화면은 프로그램에 포함된 가상 예제를 실제 브라우저에서 캡처했습니다. API 40원/T, 부형제 10원/T, 포자재비 10원/T, 공수비 20원/T, 약가 300원/T, 수율 100%로 제조원가 80원/T와 원가율 26.7%가 표시됩니다. 원가는 실제 투입량으로 계산하며 약가 간편 모델은 공식 등재 확정 결과가 아닙니다.</a:t>
+              <a:t>현행 웹 버전의 실제 입력 화면입니다. 설명용 가상 예제를 새 브라우저에서 열어 캡처했습니다. 제품명과 비고는 시나리오별로 저장합니다. 배치사이즈는 손실 발생 전 기준 수량이며 수율 기본값은 100%입니다. T는 정·캡슐 등의 단위제형입니다. 직접 입력 모드에서는 우리 제품 약가만 적용되므로 나머지 약가 조건이 회색으로 비활성화됩니다. 입력을 서버에 전송하지 않고 브라우저에서 계산합니다.</a:t>
             </a:r>
           </a:p>
         </p:txBody>
@@ -573,7 +576,217 @@
           <a:lstStyle/>
           <a:p>
             <a:r>
-              <a:t>시나리오마다 제품명과 비고를 따로 입력하며 복제본을 수정해도 원본은 유지됩니다. 실제 원료 투입량은 mg/T, 원료 단가는 원/g·원/kg·달러/g·달러/kg을 지원합니다. SF는 금액이 아니라 연차별 판매수량(T)이며 0 이상의 정수입니다. 직접 입력 약가는 전 기간에 동일하게, 예상 약가 계산은 연차별 약가로 분석합니다. 제조원가/T는 현재 조건을 전 기간에 적용합니다. 가상 예제의 1년차 SF 100,000T에서 기본안 이익은 22,000,000원, API 단가 절감안은 24,000,000원입니다. 자료는 입력값을 서버로 보내지 않는 현재 웹 버전 기준입니다.</a:t>
+              <a:t>실제 입력 화면 하단입니다. 가상 예제는 API A 20mg/T·1,000,000원/kg, API B 10mg/T·2,000,000원/kg, 부형제 100mg/T·100,000원/kg입니다. API 40원/T와 부형제 10원/T입니다. 배치 100,000T, 수율 100%, 포자재비 1,000,000원/배치와 공수비 2,000,000원/배치를 입력해 각각 10원/T와 20원/T로 계산합니다. 모든 1T 비용은 배치 전체 금액을 배치사이즈×수율로 나누어 산출합니다.</a:t>
+            </a:r>
+          </a:p>
+        </p:txBody>
+      </p:sp>
+      <p:sp>
+        <p:nvSpPr>
+          <p:cNvPr id="4" name="Slide Number Placeholder 3"/>
+          <p:cNvSpPr>
+            <a:spLocks noGrp="1"/>
+          </p:cNvSpPr>
+          <p:nvPr>
+            <p:ph type="sldNum" idx="5" sz="quarter"/>
+          </p:nvPr>
+        </p:nvSpPr>
+        <p:spPr/>
+      </p:sp>
+    </p:spTree>
+  </p:cSld>
+  <p:clrMapOvr>
+    <a:masterClrMapping/>
+  </p:clrMapOvr>
+</p:notes>
+</file>
+
+<file path=ppt/notesSlides/notesSlide3.xml><?xml version="1.0" encoding="utf-8"?>
+<p:notes xmlns:a="http://schemas.openxmlformats.org/drawingml/2006/main" xmlns:p="http://schemas.openxmlformats.org/presentationml/2006/main" xmlns:r="http://schemas.openxmlformats.org/officeDocument/2006/relationships">
+  <p:cSld>
+    <p:spTree>
+      <p:nvGrpSpPr>
+        <p:cNvPr id="1" name=""/>
+        <p:cNvGrpSpPr/>
+        <p:nvPr/>
+      </p:nvGrpSpPr>
+      <p:grpSpPr>
+        <a:xfrm>
+          <a:off x="0" y="0"/>
+          <a:ext cx="0" cy="0"/>
+          <a:chOff x="0" y="0"/>
+          <a:chExt cx="0" cy="0"/>
+        </a:xfrm>
+      </p:grpSpPr>
+      <p:sp>
+        <p:nvSpPr>
+          <p:cNvPr id="2" name="Slide Image Placeholder 1"/>
+          <p:cNvSpPr>
+            <a:spLocks noGrp="1"/>
+          </p:cNvSpPr>
+          <p:nvPr>
+            <p:ph type="sldImg" idx="2"/>
+          </p:nvPr>
+        </p:nvSpPr>
+        <p:spPr/>
+      </p:sp>
+      <p:sp>
+        <p:nvSpPr>
+          <p:cNvPr id="3" name="Notes Placeholder 2"/>
+          <p:cNvSpPr>
+            <a:spLocks noGrp="1"/>
+          </p:cNvSpPr>
+          <p:nvPr>
+            <p:ph type="body" idx="3" sz="quarter"/>
+          </p:nvPr>
+        </p:nvSpPr>
+        <p:spPr/>
+        <p:txBody>
+          <a:bodyPr/>
+          <a:lstStyle/>
+          <a:p>
+            <a:r>
+              <a:t>실제 결과 화면입니다. API 40원/T, 부형제 10원/T, 포자재비 10원/T, 공수비 20원/T로 제조원가 80원/T입니다. 약가 300원/T 대비 원가율 26.7%입니다. 도넛은 약가 전체 대비 비용과 차액을 표시하고, 오른쪽 세로 누적 막대는 제조원가 내 비용 비중을 표시합니다. 원가가 약가를 초과해도 실제 원가율을 표시하며 약가 0에서는 원가율을 계산 불가로 표시합니다.</a:t>
+            </a:r>
+          </a:p>
+        </p:txBody>
+      </p:sp>
+      <p:sp>
+        <p:nvSpPr>
+          <p:cNvPr id="4" name="Slide Number Placeholder 3"/>
+          <p:cNvSpPr>
+            <a:spLocks noGrp="1"/>
+          </p:cNvSpPr>
+          <p:nvPr>
+            <p:ph type="sldNum" idx="5" sz="quarter"/>
+          </p:nvPr>
+        </p:nvSpPr>
+        <p:spPr/>
+      </p:sp>
+    </p:spTree>
+  </p:cSld>
+  <p:clrMapOvr>
+    <a:masterClrMapping/>
+  </p:clrMapOvr>
+</p:notes>
+</file>
+
+<file path=ppt/notesSlides/notesSlide4.xml><?xml version="1.0" encoding="utf-8"?>
+<p:notes xmlns:a="http://schemas.openxmlformats.org/drawingml/2006/main" xmlns:p="http://schemas.openxmlformats.org/presentationml/2006/main" xmlns:r="http://schemas.openxmlformats.org/officeDocument/2006/relationships">
+  <p:cSld>
+    <p:spTree>
+      <p:nvGrpSpPr>
+        <p:cNvPr id="1" name=""/>
+        <p:cNvGrpSpPr/>
+        <p:nvPr/>
+      </p:nvGrpSpPr>
+      <p:grpSpPr>
+        <a:xfrm>
+          <a:off x="0" y="0"/>
+          <a:ext cx="0" cy="0"/>
+          <a:chOff x="0" y="0"/>
+          <a:chExt cx="0" cy="0"/>
+        </a:xfrm>
+      </p:grpSpPr>
+      <p:sp>
+        <p:nvSpPr>
+          <p:cNvPr id="2" name="Slide Image Placeholder 1"/>
+          <p:cNvSpPr>
+            <a:spLocks noGrp="1"/>
+          </p:cNvSpPr>
+          <p:nvPr>
+            <p:ph type="sldImg" idx="2"/>
+          </p:nvPr>
+        </p:nvSpPr>
+        <p:spPr/>
+      </p:sp>
+      <p:sp>
+        <p:nvSpPr>
+          <p:cNvPr id="3" name="Notes Placeholder 2"/>
+          <p:cNvSpPr>
+            <a:spLocks noGrp="1"/>
+          </p:cNvSpPr>
+          <p:nvPr>
+            <p:ph type="body" idx="3" sz="quarter"/>
+          </p:nvPr>
+        </p:nvSpPr>
+        <p:spPr/>
+        <p:txBody>
+          <a:bodyPr/>
+          <a:lstStyle/>
+          <a:p>
+            <a:r>
+              <a:t>실제 시나리오 비교표 상단을 발췌했습니다. 가상 예제의 두 번째 시나리오는 API A와 B의 구매단가를 절반으로 낮추어 제조원가가 80원/T에서 60원/T, 원가율이 26.7%에서 20.0%가 됩니다. 표 아래에는 비용 구성 도넛, 1~8년차 약가·제조원가 막대그래프, 배치당/1T당 비용이 이어집니다. 연차를 누르면 해당 시나리오의 비용 구성 도넛이 바뀝니다. 탭 드래그로 순서를 변경하고 비교표 출력으로 인쇄합니다. JSON 파일로 모든 시나리오와 SF를 저장합니다.</a:t>
+            </a:r>
+          </a:p>
+        </p:txBody>
+      </p:sp>
+      <p:sp>
+        <p:nvSpPr>
+          <p:cNvPr id="4" name="Slide Number Placeholder 3"/>
+          <p:cNvSpPr>
+            <a:spLocks noGrp="1"/>
+          </p:cNvSpPr>
+          <p:nvPr>
+            <p:ph type="sldNum" idx="5" sz="quarter"/>
+          </p:nvPr>
+        </p:nvSpPr>
+        <p:spPr/>
+      </p:sp>
+    </p:spTree>
+  </p:cSld>
+  <p:clrMapOvr>
+    <a:masterClrMapping/>
+  </p:clrMapOvr>
+</p:notes>
+</file>
+
+<file path=ppt/notesSlides/notesSlide5.xml><?xml version="1.0" encoding="utf-8"?>
+<p:notes xmlns:a="http://schemas.openxmlformats.org/drawingml/2006/main" xmlns:p="http://schemas.openxmlformats.org/presentationml/2006/main" xmlns:r="http://schemas.openxmlformats.org/officeDocument/2006/relationships">
+  <p:cSld>
+    <p:spTree>
+      <p:nvGrpSpPr>
+        <p:cNvPr id="1" name=""/>
+        <p:cNvGrpSpPr/>
+        <p:nvPr/>
+      </p:nvGrpSpPr>
+      <p:grpSpPr>
+        <a:xfrm>
+          <a:off x="0" y="0"/>
+          <a:ext cx="0" cy="0"/>
+          <a:chOff x="0" y="0"/>
+          <a:chExt cx="0" cy="0"/>
+        </a:xfrm>
+      </p:grpSpPr>
+      <p:sp>
+        <p:nvSpPr>
+          <p:cNvPr id="2" name="Slide Image Placeholder 1"/>
+          <p:cNvSpPr>
+            <a:spLocks noGrp="1"/>
+          </p:cNvSpPr>
+          <p:nvPr>
+            <p:ph type="sldImg" idx="2"/>
+          </p:nvPr>
+        </p:nvSpPr>
+        <p:spPr/>
+      </p:sp>
+      <p:sp>
+        <p:nvSpPr>
+          <p:cNvPr id="3" name="Notes Placeholder 2"/>
+          <p:cNvSpPr>
+            <a:spLocks noGrp="1"/>
+          </p:cNvSpPr>
+          <p:nvPr>
+            <p:ph type="body" idx="3" sz="quarter"/>
+          </p:nvPr>
+        </p:nvSpPr>
+        <p:spPr/>
+        <p:txBody>
+          <a:bodyPr/>
+          <a:lstStyle/>
+          <a:p>
+            <a:r>
+              <a:t>실제 SF 입력표와 실제 이익 분석 그래프입니다. SF는 금액이 아니라 판매수량 T이며 0 이상의 정수로 입력합니다. 예제 8년 SF는 100,000·180,000·250,000·350,000·450,000·550,000·650,000·750,000T입니다. 기본안의 1년차 이익은 100,000×(300-80)=22,000,000원, API 단가 절감안은 100,000×(300-60)=24,000,000원입니다. 연간과 누적 그래프는 같은 연차의 시나리오 막대를 나란히 표시합니다. 누적 그래프는 1년차부터 해당 연차까지의 누계를 매년 표시합니다. 보험약가를 판매단가로 쓰며 현재 제조원가/T를 전체 기간에 적용합니다. 판관비·개발비·세금을 반영한 순이익은 아닙니다. 공통 SF 또는 시나리오별 별도 SF를 입력할 수 있습니다.</a:t>
             </a:r>
           </a:p>
         </p:txBody>
@@ -3671,7 +3884,7 @@
                 <a:latin typeface="맑은 고딕"/>
                 <a:ea typeface="맑은 고딕"/>
               </a:rPr>
-              <a:t>SIMULATOR OVERVIEW</a:t>
+              <a:t>01  INPUT · BASIC SETTINGS</a:t>
             </a:r>
           </a:p>
         </p:txBody>
@@ -3763,7 +3976,7 @@
                 <a:latin typeface="맑은 고딕"/>
                 <a:ea typeface="맑은 고딕"/>
               </a:rPr>
-              <a:t>의약품 제조원가율 시뮬레이터</a:t>
+              <a:t>제품·생산조건과 약가를 입력합니다</a:t>
             </a:r>
           </a:p>
         </p:txBody>
@@ -3809,7 +4022,7 @@
                 <a:latin typeface="맑은 고딕"/>
                 <a:ea typeface="맑은 고딕"/>
               </a:rPr>
-              <a:t>처방부터 원가율·이익까지, 조건을 바꾸며 바로 비교합니다.</a:t>
+              <a:t>처방의 제조원가율을 계산하고, 조건을 바꾼 시나리오와 예상이익을 비교하는 도구입니다.</a:t>
             </a:r>
           </a:p>
         </p:txBody>
@@ -3902,7 +4115,7 @@
                 <a:latin typeface="맑은 고딕"/>
                 <a:ea typeface="맑은 고딕"/>
               </a:rPr>
-              <a:t>01 / 02</a:t>
+              <a:t>01 / 05</a:t>
             </a:r>
           </a:p>
         </p:txBody>
@@ -3915,8 +4128,8 @@
         </p:nvSpPr>
         <p:spPr>
           <a:xfrm>
-            <a:off x="566928" y="1810512"/>
-            <a:ext cx="1673352" cy="292608"/>
+            <a:off x="566928" y="1755648"/>
+            <a:ext cx="1901952" cy="292608"/>
           </a:xfrm>
           <a:prstGeom prst="roundRect">
             <a:avLst>
@@ -3960,8 +4173,8 @@
         </p:nvSpPr>
         <p:spPr>
           <a:xfrm>
-            <a:off x="658368" y="1851660"/>
-            <a:ext cx="1490472" cy="182880"/>
+            <a:off x="658368" y="1796795"/>
+            <a:ext cx="1719072" cy="182880"/>
           </a:xfrm>
           <a:prstGeom prst="rect">
             <a:avLst/>
@@ -3993,7 +4206,7 @@
                 <a:latin typeface="맑은 고딕"/>
                 <a:ea typeface="맑은 고딕"/>
               </a:rPr>
-              <a:t>설치 없이 웹 실행</a:t>
+              <a:t>실제 입력 화면 · 상단</a:t>
             </a:r>
           </a:p>
         </p:txBody>
@@ -4006,8 +4219,8 @@
         </p:nvSpPr>
         <p:spPr>
           <a:xfrm>
-            <a:off x="2350008" y="1810512"/>
-            <a:ext cx="1517904" cy="292608"/>
+            <a:off x="9875520" y="1755648"/>
+            <a:ext cx="1746504" cy="292608"/>
           </a:xfrm>
           <a:prstGeom prst="roundRect">
             <a:avLst>
@@ -4051,8 +4264,8 @@
         </p:nvSpPr>
         <p:spPr>
           <a:xfrm>
-            <a:off x="2441448" y="1851660"/>
-            <a:ext cx="1335024" cy="182880"/>
+            <a:off x="9966960" y="1796795"/>
+            <a:ext cx="1563624" cy="182880"/>
           </a:xfrm>
           <a:prstGeom prst="rect">
             <a:avLst/>
@@ -4084,26 +4297,72 @@
                 <a:latin typeface="맑은 고딕"/>
                 <a:ea typeface="맑은 고딕"/>
               </a:rPr>
-              <a:t>최대 4개 시나리오</a:t>
-            </a:r>
-          </a:p>
-        </p:txBody>
-      </p:sp>
-      <p:sp>
-        <p:nvSpPr>
-          <p:cNvPr id="13" name="Rounded Rectangle 12"/>
+              <a:t>설명용 가상 예제</a:t>
+            </a:r>
+          </a:p>
+        </p:txBody>
+      </p:sp>
+      <p:pic>
+        <p:nvPicPr>
+          <p:cNvPr id="13" name="Picture 12" descr="input-context.png"/>
+          <p:cNvPicPr>
+            <a:picLocks noChangeAspect="1"/>
+          </p:cNvPicPr>
+          <p:nvPr/>
+        </p:nvPicPr>
+        <p:blipFill>
+          <a:blip r:embed="rId3"/>
+          <a:stretch>
+            <a:fillRect/>
+          </a:stretch>
+        </p:blipFill>
+        <p:spPr>
+          <a:xfrm>
+            <a:off x="566928" y="2139696"/>
+            <a:ext cx="11055096" cy="873709"/>
+          </a:xfrm>
+          <a:prstGeom prst="rect">
+            <a:avLst/>
+          </a:prstGeom>
+        </p:spPr>
+      </p:pic>
+      <p:pic>
+        <p:nvPicPr>
+          <p:cNvPr id="14" name="Picture 13" descr="input-pricing.png"/>
+          <p:cNvPicPr>
+            <a:picLocks noChangeAspect="1"/>
+          </p:cNvPicPr>
+          <p:nvPr/>
+        </p:nvPicPr>
+        <p:blipFill>
+          <a:blip r:embed="rId4"/>
+          <a:stretch>
+            <a:fillRect/>
+          </a:stretch>
+        </p:blipFill>
+        <p:spPr>
+          <a:xfrm>
+            <a:off x="566928" y="3127248"/>
+            <a:ext cx="7534656" cy="3196152"/>
+          </a:xfrm>
+          <a:prstGeom prst="rect">
+            <a:avLst/>
+          </a:prstGeom>
+        </p:spPr>
+      </p:pic>
+      <p:sp>
+        <p:nvSpPr>
+          <p:cNvPr id="15" name="Oval 14"/>
           <p:cNvSpPr/>
           <p:nvPr/>
         </p:nvSpPr>
         <p:spPr>
           <a:xfrm>
-            <a:off x="3977639" y="1810512"/>
-            <a:ext cx="1627632" cy="292608"/>
-          </a:xfrm>
-          <a:prstGeom prst="roundRect">
-            <a:avLst>
-              <a:gd name="adj" fmla="val 12000"/>
-            </a:avLst>
+            <a:off x="8366760" y="3108960"/>
+            <a:ext cx="320040" cy="320040"/>
+          </a:xfrm>
+          <a:prstGeom prst="ellipse">
+            <a:avLst/>
           </a:prstGeom>
           <a:solidFill>
             <a:srgbClr val="E7F4F2"/>
@@ -4127,23 +4386,32 @@
           </a:fontRef>
         </p:style>
         <p:txBody>
-          <a:bodyPr rtlCol="0" anchor="ctr"/>
+          <a:bodyPr rtlCol="0" anchor="ctr" lIns="0" rIns="0" tIns="0" bIns="0"/>
           <a:lstStyle/>
           <a:p>
             <a:pPr algn="ctr"/>
-          </a:p>
-        </p:txBody>
-      </p:sp>
-      <p:sp>
-        <p:nvSpPr>
-          <p:cNvPr id="14" name="TextBox 13"/>
+            <a:r>
+              <a:rPr sz="1100" b="1">
+                <a:solidFill>
+                  <a:srgbClr val="087F82"/>
+                </a:solidFill>
+                <a:latin typeface="맑은 고딕"/>
+              </a:rPr>
+              <a:t>01</a:t>
+            </a:r>
+          </a:p>
+        </p:txBody>
+      </p:sp>
+      <p:sp>
+        <p:nvSpPr>
+          <p:cNvPr id="16" name="TextBox 15"/>
           <p:cNvSpPr txBox="1"/>
           <p:nvPr/>
         </p:nvSpPr>
         <p:spPr>
           <a:xfrm>
-            <a:off x="4069079" y="1851660"/>
-            <a:ext cx="1444752" cy="182880"/>
+            <a:off x="8796528" y="3095244"/>
+            <a:ext cx="2788920" cy="301752"/>
           </a:xfrm>
           <a:prstGeom prst="rect">
             <a:avLst/>
@@ -4168,27 +4436,96 @@
               </a:spcAft>
             </a:pPr>
             <a:r>
-              <a:rPr sz="1030" b="1" lang="ko-KR">
-                <a:solidFill>
-                  <a:srgbClr val="087F82"/>
+              <a:rPr sz="1520" b="1" lang="ko-KR">
+                <a:solidFill>
+                  <a:srgbClr val="153C4D"/>
                 </a:solidFill>
                 <a:latin typeface="맑은 고딕"/>
                 <a:ea typeface="맑은 고딕"/>
               </a:rPr>
-              <a:t>JSON 저장·복원</a:t>
-            </a:r>
-          </a:p>
-        </p:txBody>
-      </p:sp>
-      <p:sp>
-        <p:nvSpPr>
-          <p:cNvPr id="15" name="Oval 14"/>
+              <a:t>제품·비고</a:t>
+            </a:r>
+          </a:p>
+        </p:txBody>
+      </p:sp>
+      <p:sp>
+        <p:nvSpPr>
+          <p:cNvPr id="17" name="TextBox 16"/>
+          <p:cNvSpPr txBox="1"/>
+          <p:nvPr/>
+        </p:nvSpPr>
+        <p:spPr>
+          <a:xfrm>
+            <a:off x="8796528" y="3465576"/>
+            <a:ext cx="2788920" cy="640080"/>
+          </a:xfrm>
+          <a:prstGeom prst="rect">
+            <a:avLst/>
+          </a:prstGeom>
+          <a:noFill/>
+        </p:spPr>
+        <p:txBody>
+          <a:bodyPr wrap="square" lIns="0" rIns="0" tIns="0" bIns="0">
+            <a:spAutoFit/>
+          </a:bodyPr>
+          <a:lstStyle/>
+          <a:p>
+            <a:pPr algn="l">
+              <a:lnSpc>
+                <a:spcPct val="116000"/>
+              </a:lnSpc>
+              <a:spcBef>
+                <a:spcPts val="0"/>
+              </a:spcBef>
+              <a:spcAft>
+                <a:spcPts val="100"/>
+              </a:spcAft>
+            </a:pPr>
+            <a:r>
+              <a:rPr sz="1250" b="0" lang="ko-KR">
+                <a:solidFill>
+                  <a:srgbClr val="637F8D"/>
+                </a:solidFill>
+                <a:latin typeface="맑은 고딕"/>
+                <a:ea typeface="맑은 고딕"/>
+              </a:rPr>
+              <a:t>각 시나리오의 제품명과</a:t>
+            </a:r>
+          </a:p>
+          <a:p>
+            <a:pPr algn="l">
+              <a:lnSpc>
+                <a:spcPct val="116000"/>
+              </a:lnSpc>
+              <a:spcBef>
+                <a:spcPts val="0"/>
+              </a:spcBef>
+              <a:spcAft>
+                <a:spcPts val="100"/>
+              </a:spcAft>
+            </a:pPr>
+            <a:r>
+              <a:rPr sz="1250" b="0" lang="ko-KR">
+                <a:solidFill>
+                  <a:srgbClr val="637F8D"/>
+                </a:solidFill>
+                <a:latin typeface="맑은 고딕"/>
+                <a:ea typeface="맑은 고딕"/>
+              </a:rPr>
+              <a:t>설명을 따로 입력합니다.</a:t>
+            </a:r>
+          </a:p>
+        </p:txBody>
+      </p:sp>
+      <p:sp>
+        <p:nvSpPr>
+          <p:cNvPr id="18" name="Oval 17"/>
           <p:cNvSpPr/>
           <p:nvPr/>
         </p:nvSpPr>
         <p:spPr>
           <a:xfrm>
-            <a:off x="585216" y="2514600"/>
+            <a:off x="8366760" y="4133087"/>
             <a:ext cx="320040" cy="320040"/>
           </a:xfrm>
           <a:prstGeom prst="ellipse">
@@ -4227,21 +4564,21 @@
                 </a:solidFill>
                 <a:latin typeface="맑은 고딕"/>
               </a:rPr>
-              <a:t>01</a:t>
-            </a:r>
-          </a:p>
-        </p:txBody>
-      </p:sp>
-      <p:sp>
-        <p:nvSpPr>
-          <p:cNvPr id="16" name="TextBox 15"/>
+              <a:t>02</a:t>
+            </a:r>
+          </a:p>
+        </p:txBody>
+      </p:sp>
+      <p:sp>
+        <p:nvSpPr>
+          <p:cNvPr id="19" name="TextBox 18"/>
           <p:cNvSpPr txBox="1"/>
           <p:nvPr/>
         </p:nvSpPr>
         <p:spPr>
           <a:xfrm>
-            <a:off x="1051560" y="2505456"/>
-            <a:ext cx="3474720" cy="292608"/>
+            <a:off x="8796528" y="4119372"/>
+            <a:ext cx="2788920" cy="301752"/>
           </a:xfrm>
           <a:prstGeom prst="rect">
             <a:avLst/>
@@ -4266,28 +4603,28 @@
               </a:spcAft>
             </a:pPr>
             <a:r>
-              <a:rPr sz="1800" b="1" lang="ko-KR">
+              <a:rPr sz="1520" b="1" lang="ko-KR">
                 <a:solidFill>
                   <a:srgbClr val="153C4D"/>
                 </a:solidFill>
                 <a:latin typeface="맑은 고딕"/>
                 <a:ea typeface="맑은 고딕"/>
               </a:rPr>
-              <a:t>원가 계산</a:t>
-            </a:r>
-          </a:p>
-        </p:txBody>
-      </p:sp>
-      <p:sp>
-        <p:nvSpPr>
-          <p:cNvPr id="17" name="TextBox 16"/>
+              <a:t>생산조건 입력</a:t>
+            </a:r>
+          </a:p>
+        </p:txBody>
+      </p:sp>
+      <p:sp>
+        <p:nvSpPr>
+          <p:cNvPr id="20" name="TextBox 19"/>
           <p:cNvSpPr txBox="1"/>
           <p:nvPr/>
         </p:nvSpPr>
         <p:spPr>
           <a:xfrm>
-            <a:off x="1051560" y="2852928"/>
-            <a:ext cx="3538728" cy="557784"/>
+            <a:off x="8796528" y="4489703"/>
+            <a:ext cx="2788920" cy="640080"/>
           </a:xfrm>
           <a:prstGeom prst="rect">
             <a:avLst/>
@@ -4312,14 +4649,14 @@
               </a:spcAft>
             </a:pPr>
             <a:r>
-              <a:rPr sz="1410" b="0" lang="ko-KR">
+              <a:rPr sz="1250" b="0" lang="ko-KR">
                 <a:solidFill>
                   <a:srgbClr val="637F8D"/>
                 </a:solidFill>
                 <a:latin typeface="맑은 고딕"/>
                 <a:ea typeface="맑은 고딕"/>
               </a:rPr>
-              <a:t>API·부형제·포자재비·공수비로</a:t>
+              <a:t>배치사이즈·수율·포장형태,</a:t>
             </a:r>
           </a:p>
           <a:p>
@@ -4335,27 +4672,27 @@
               </a:spcAft>
             </a:pPr>
             <a:r>
-              <a:rPr sz="1410" b="0" lang="ko-KR">
+              <a:rPr sz="1250" b="0" lang="ko-KR">
                 <a:solidFill>
                   <a:srgbClr val="637F8D"/>
                 </a:solidFill>
                 <a:latin typeface="맑은 고딕"/>
                 <a:ea typeface="맑은 고딕"/>
               </a:rPr>
-              <a:t>1T당 제조원가와 원가율 계산</a:t>
-            </a:r>
-          </a:p>
-        </p:txBody>
-      </p:sp>
-      <p:sp>
-        <p:nvSpPr>
-          <p:cNvPr id="18" name="Oval 17"/>
+              <a:t>달러 환율을 입력합니다.</a:t>
+            </a:r>
+          </a:p>
+        </p:txBody>
+      </p:sp>
+      <p:sp>
+        <p:nvSpPr>
+          <p:cNvPr id="21" name="Oval 20"/>
           <p:cNvSpPr/>
           <p:nvPr/>
         </p:nvSpPr>
         <p:spPr>
           <a:xfrm>
-            <a:off x="585216" y="3429000"/>
+            <a:off x="8366760" y="5157216"/>
             <a:ext cx="320040" cy="320040"/>
           </a:xfrm>
           <a:prstGeom prst="ellipse">
@@ -4394,21 +4731,21 @@
                 </a:solidFill>
                 <a:latin typeface="맑은 고딕"/>
               </a:rPr>
-              <a:t>02</a:t>
-            </a:r>
-          </a:p>
-        </p:txBody>
-      </p:sp>
-      <p:sp>
-        <p:nvSpPr>
-          <p:cNvPr id="19" name="TextBox 18"/>
+              <a:t>03</a:t>
+            </a:r>
+          </a:p>
+        </p:txBody>
+      </p:sp>
+      <p:sp>
+        <p:nvSpPr>
+          <p:cNvPr id="22" name="TextBox 21"/>
           <p:cNvSpPr txBox="1"/>
           <p:nvPr/>
         </p:nvSpPr>
         <p:spPr>
           <a:xfrm>
-            <a:off x="1051560" y="3419856"/>
-            <a:ext cx="3474720" cy="292608"/>
+            <a:off x="8796528" y="5143500"/>
+            <a:ext cx="2788920" cy="301752"/>
           </a:xfrm>
           <a:prstGeom prst="rect">
             <a:avLst/>
@@ -4433,28 +4770,28 @@
               </a:spcAft>
             </a:pPr>
             <a:r>
-              <a:rPr sz="1800" b="1" lang="ko-KR">
+              <a:rPr sz="1520" b="1" lang="ko-KR">
                 <a:solidFill>
                   <a:srgbClr val="153C4D"/>
                 </a:solidFill>
                 <a:latin typeface="맑은 고딕"/>
                 <a:ea typeface="맑은 고딕"/>
               </a:rPr>
-              <a:t>시나리오 비교</a:t>
-            </a:r>
-          </a:p>
-        </p:txBody>
-      </p:sp>
-      <p:sp>
-        <p:nvSpPr>
-          <p:cNvPr id="20" name="TextBox 19"/>
+              <a:t>약가 입력 방식</a:t>
+            </a:r>
+          </a:p>
+        </p:txBody>
+      </p:sp>
+      <p:sp>
+        <p:nvSpPr>
+          <p:cNvPr id="23" name="TextBox 22"/>
           <p:cNvSpPr txBox="1"/>
           <p:nvPr/>
         </p:nvSpPr>
         <p:spPr>
           <a:xfrm>
-            <a:off x="1051560" y="3767328"/>
-            <a:ext cx="3538728" cy="557784"/>
+            <a:off x="8796528" y="5513831"/>
+            <a:ext cx="2788920" cy="640080"/>
           </a:xfrm>
           <a:prstGeom prst="rect">
             <a:avLst/>
@@ -4479,14 +4816,14 @@
               </a:spcAft>
             </a:pPr>
             <a:r>
-              <a:rPr sz="1410" b="0" lang="ko-KR">
+              <a:rPr sz="1250" b="0" lang="ko-KR">
                 <a:solidFill>
                   <a:srgbClr val="637F8D"/>
                 </a:solidFill>
                 <a:latin typeface="맑은 고딕"/>
                 <a:ea typeface="맑은 고딕"/>
               </a:rPr>
-              <a:t>현재 입력을 복제하고 조건을 바꿔</a:t>
+              <a:t>직접 입력은 우리 제품 약가,</a:t>
             </a:r>
           </a:p>
           <a:p>
@@ -4502,80 +4839,28 @@
               </a:spcAft>
             </a:pPr>
             <a:r>
-              <a:rPr sz="1410" b="0" lang="ko-KR">
+              <a:rPr sz="1250" b="0" lang="ko-KR">
                 <a:solidFill>
                   <a:srgbClr val="637F8D"/>
                 </a:solidFill>
                 <a:latin typeface="맑은 고딕"/>
                 <a:ea typeface="맑은 고딕"/>
               </a:rPr>
-              <a:t>공급처·단가·수율별 차이 비교</a:t>
-            </a:r>
-          </a:p>
-        </p:txBody>
-      </p:sp>
-      <p:sp>
-        <p:nvSpPr>
-          <p:cNvPr id="21" name="Oval 20"/>
-          <p:cNvSpPr/>
-          <p:nvPr/>
-        </p:nvSpPr>
-        <p:spPr>
-          <a:xfrm>
-            <a:off x="585216" y="4343400"/>
-            <a:ext cx="320040" cy="320040"/>
-          </a:xfrm>
-          <a:prstGeom prst="ellipse">
-            <a:avLst/>
-          </a:prstGeom>
-          <a:solidFill>
-            <a:srgbClr val="E7F4F2"/>
-          </a:solidFill>
-          <a:ln>
-            <a:noFill/>
-          </a:ln>
-        </p:spPr>
-        <p:style>
-          <a:lnRef idx="1">
-            <a:schemeClr val="accent1"/>
-          </a:lnRef>
-          <a:fillRef idx="3">
-            <a:schemeClr val="accent1"/>
-          </a:fillRef>
-          <a:effectRef idx="2">
-            <a:schemeClr val="accent1"/>
-          </a:effectRef>
-          <a:fontRef idx="minor">
-            <a:schemeClr val="lt1"/>
-          </a:fontRef>
-        </p:style>
-        <p:txBody>
-          <a:bodyPr rtlCol="0" anchor="ctr" lIns="0" rIns="0" tIns="0" bIns="0"/>
-          <a:lstStyle/>
-          <a:p>
-            <a:pPr algn="ctr"/>
-            <a:r>
-              <a:rPr sz="1100" b="1">
-                <a:solidFill>
-                  <a:srgbClr val="087F82"/>
-                </a:solidFill>
-                <a:latin typeface="맑은 고딕"/>
-              </a:rPr>
-              <a:t>03</a:t>
-            </a:r>
-          </a:p>
-        </p:txBody>
-      </p:sp>
-      <p:sp>
-        <p:nvSpPr>
-          <p:cNvPr id="22" name="TextBox 21"/>
+              <a:t>예상 계산은 조건을 선택합니다.</a:t>
+            </a:r>
+          </a:p>
+        </p:txBody>
+      </p:sp>
+      <p:sp>
+        <p:nvSpPr>
+          <p:cNvPr id="24" name="TextBox 23"/>
           <p:cNvSpPr txBox="1"/>
           <p:nvPr/>
         </p:nvSpPr>
         <p:spPr>
           <a:xfrm>
-            <a:off x="1051560" y="4334256"/>
-            <a:ext cx="3474720" cy="292608"/>
+            <a:off x="594360" y="6373368"/>
+            <a:ext cx="10972800" cy="155448"/>
           </a:xfrm>
           <a:prstGeom prst="rect">
             <a:avLst/>
@@ -4600,383 +4885,14 @@
               </a:spcAft>
             </a:pPr>
             <a:r>
-              <a:rPr sz="1800" b="1" lang="ko-KR">
-                <a:solidFill>
-                  <a:srgbClr val="153C4D"/>
+              <a:rPr sz="890" b="0" lang="ko-KR">
+                <a:solidFill>
+                  <a:srgbClr val="637F8D"/>
                 </a:solidFill>
                 <a:latin typeface="맑은 고딕"/>
                 <a:ea typeface="맑은 고딕"/>
               </a:rPr>
-              <a:t>SF 이익 분석</a:t>
-            </a:r>
-          </a:p>
-        </p:txBody>
-      </p:sp>
-      <p:sp>
-        <p:nvSpPr>
-          <p:cNvPr id="23" name="TextBox 22"/>
-          <p:cNvSpPr txBox="1"/>
-          <p:nvPr/>
-        </p:nvSpPr>
-        <p:spPr>
-          <a:xfrm>
-            <a:off x="1051560" y="4681728"/>
-            <a:ext cx="3538728" cy="557784"/>
-          </a:xfrm>
-          <a:prstGeom prst="rect">
-            <a:avLst/>
-          </a:prstGeom>
-          <a:noFill/>
-        </p:spPr>
-        <p:txBody>
-          <a:bodyPr wrap="square" lIns="0" rIns="0" tIns="0" bIns="0">
-            <a:spAutoFit/>
-          </a:bodyPr>
-          <a:lstStyle/>
-          <a:p>
-            <a:pPr algn="l">
-              <a:lnSpc>
-                <a:spcPct val="116000"/>
-              </a:lnSpc>
-              <a:spcBef>
-                <a:spcPts val="0"/>
-              </a:spcBef>
-              <a:spcAft>
-                <a:spcPts val="100"/>
-              </a:spcAft>
-            </a:pPr>
-            <a:r>
-              <a:rPr sz="1410" b="0" lang="ko-KR">
-                <a:solidFill>
-                  <a:srgbClr val="637F8D"/>
-                </a:solidFill>
-                <a:latin typeface="맑은 고딕"/>
-                <a:ea typeface="맑은 고딕"/>
-              </a:rPr>
-              <a:t>연차별 판매수량(T)을 입력해</a:t>
-            </a:r>
-          </a:p>
-          <a:p>
-            <a:pPr algn="l">
-              <a:lnSpc>
-                <a:spcPct val="116000"/>
-              </a:lnSpc>
-              <a:spcBef>
-                <a:spcPts val="0"/>
-              </a:spcBef>
-              <a:spcAft>
-                <a:spcPts val="100"/>
-              </a:spcAft>
-            </a:pPr>
-            <a:r>
-              <a:rPr sz="1410" b="0" lang="ko-KR">
-                <a:solidFill>
-                  <a:srgbClr val="637F8D"/>
-                </a:solidFill>
-                <a:latin typeface="맑은 고딕"/>
-                <a:ea typeface="맑은 고딕"/>
-              </a:rPr>
-              <a:t>연간·누적 예상이익 확인</a:t>
-            </a:r>
-          </a:p>
-        </p:txBody>
-      </p:sp>
-      <p:sp>
-        <p:nvSpPr>
-          <p:cNvPr id="24" name="TextBox 23"/>
-          <p:cNvSpPr txBox="1"/>
-          <p:nvPr/>
-        </p:nvSpPr>
-        <p:spPr>
-          <a:xfrm>
-            <a:off x="4846320" y="2231136"/>
-            <a:ext cx="6720840" cy="210312"/>
-          </a:xfrm>
-          <a:prstGeom prst="rect">
-            <a:avLst/>
-          </a:prstGeom>
-          <a:noFill/>
-        </p:spPr>
-        <p:txBody>
-          <a:bodyPr wrap="square" lIns="0" rIns="0" tIns="0" bIns="0">
-            <a:spAutoFit/>
-          </a:bodyPr>
-          <a:lstStyle/>
-          <a:p>
-            <a:pPr algn="l">
-              <a:lnSpc>
-                <a:spcPct val="116000"/>
-              </a:lnSpc>
-              <a:spcBef>
-                <a:spcPts val="0"/>
-              </a:spcBef>
-              <a:spcAft>
-                <a:spcPts val="100"/>
-              </a:spcAft>
-            </a:pPr>
-            <a:r>
-              <a:rPr sz="1110" b="0" lang="ko-KR">
-                <a:solidFill>
-                  <a:srgbClr val="637F8D"/>
-                </a:solidFill>
-                <a:latin typeface="맑은 고딕"/>
-                <a:ea typeface="맑은 고딕"/>
-              </a:rPr>
-              <a:t>실제 결과 화면  |  설명용 가상 예제</a:t>
-            </a:r>
-          </a:p>
-        </p:txBody>
-      </p:sp>
-      <p:sp>
-        <p:nvSpPr>
-          <p:cNvPr id="25" name="Rounded Rectangle 24"/>
-          <p:cNvSpPr/>
-          <p:nvPr/>
-        </p:nvSpPr>
-        <p:spPr>
-          <a:xfrm>
-            <a:off x="4791456" y="2523744"/>
-            <a:ext cx="6830568" cy="2706624"/>
-          </a:xfrm>
-          <a:prstGeom prst="roundRect">
-            <a:avLst>
-              <a:gd name="adj" fmla="val 12000"/>
-            </a:avLst>
-          </a:prstGeom>
-          <a:solidFill>
-            <a:srgbClr val="FFFFFF"/>
-          </a:solidFill>
-          <a:ln w="8890">
-            <a:solidFill>
-              <a:srgbClr val="D9E5E8"/>
-            </a:solidFill>
-          </a:ln>
-        </p:spPr>
-        <p:style>
-          <a:lnRef idx="1">
-            <a:schemeClr val="accent1"/>
-          </a:lnRef>
-          <a:fillRef idx="3">
-            <a:schemeClr val="accent1"/>
-          </a:fillRef>
-          <a:effectRef idx="2">
-            <a:schemeClr val="accent1"/>
-          </a:effectRef>
-          <a:fontRef idx="minor">
-            <a:schemeClr val="lt1"/>
-          </a:fontRef>
-        </p:style>
-        <p:txBody>
-          <a:bodyPr rtlCol="0" anchor="ctr"/>
-          <a:lstStyle/>
-          <a:p>
-            <a:pPr algn="ctr"/>
-          </a:p>
-        </p:txBody>
-      </p:sp>
-      <p:pic>
-        <p:nvPicPr>
-          <p:cNvPr id="26" name="Picture 25" descr="results.png"/>
-          <p:cNvPicPr>
-            <a:picLocks noChangeAspect="1"/>
-          </p:cNvPicPr>
-          <p:nvPr/>
-        </p:nvPicPr>
-        <p:blipFill>
-          <a:blip r:embed="rId3"/>
-          <a:stretch>
-            <a:fillRect/>
-          </a:stretch>
-        </p:blipFill>
-        <p:spPr>
-          <a:xfrm>
-            <a:off x="4846320" y="2569464"/>
-            <a:ext cx="6720840" cy="2615018"/>
-          </a:xfrm>
-          <a:prstGeom prst="rect">
-            <a:avLst/>
-          </a:prstGeom>
-        </p:spPr>
-      </p:pic>
-      <p:sp>
-        <p:nvSpPr>
-          <p:cNvPr id="27" name="TextBox 26"/>
-          <p:cNvSpPr txBox="1"/>
-          <p:nvPr/>
-        </p:nvSpPr>
-        <p:spPr>
-          <a:xfrm>
-            <a:off x="4864608" y="5303520"/>
-            <a:ext cx="6711696" cy="219456"/>
-          </a:xfrm>
-          <a:prstGeom prst="rect">
-            <a:avLst/>
-          </a:prstGeom>
-          <a:noFill/>
-        </p:spPr>
-        <p:txBody>
-          <a:bodyPr wrap="square" lIns="0" rIns="0" tIns="0" bIns="0">
-            <a:spAutoFit/>
-          </a:bodyPr>
-          <a:lstStyle/>
-          <a:p>
-            <a:pPr algn="l">
-              <a:lnSpc>
-                <a:spcPct val="116000"/>
-              </a:lnSpc>
-              <a:spcBef>
-                <a:spcPts val="0"/>
-              </a:spcBef>
-              <a:spcAft>
-                <a:spcPts val="100"/>
-              </a:spcAft>
-            </a:pPr>
-            <a:r>
-              <a:rPr sz="1280" b="1" lang="ko-KR">
-                <a:solidFill>
-                  <a:srgbClr val="087F82"/>
-                </a:solidFill>
-                <a:latin typeface="맑은 고딕"/>
-                <a:ea typeface="맑은 고딕"/>
-              </a:rPr>
-              <a:t>약가 300원/T → 제조원가 80원/T → 원가율 26.7%</a:t>
-            </a:r>
-          </a:p>
-        </p:txBody>
-      </p:sp>
-      <p:sp>
-        <p:nvSpPr>
-          <p:cNvPr id="28" name="Rounded Rectangle 27"/>
-          <p:cNvSpPr/>
-          <p:nvPr/>
-        </p:nvSpPr>
-        <p:spPr>
-          <a:xfrm>
-            <a:off x="566928" y="5687568"/>
-            <a:ext cx="11055096" cy="621792"/>
-          </a:xfrm>
-          <a:prstGeom prst="roundRect">
-            <a:avLst>
-              <a:gd name="adj" fmla="val 12000"/>
-            </a:avLst>
-          </a:prstGeom>
-          <a:solidFill>
-            <a:srgbClr val="153C4D"/>
-          </a:solidFill>
-          <a:ln>
-            <a:noFill/>
-          </a:ln>
-        </p:spPr>
-        <p:style>
-          <a:lnRef idx="1">
-            <a:schemeClr val="accent1"/>
-          </a:lnRef>
-          <a:fillRef idx="3">
-            <a:schemeClr val="accent1"/>
-          </a:fillRef>
-          <a:effectRef idx="2">
-            <a:schemeClr val="accent1"/>
-          </a:effectRef>
-          <a:fontRef idx="minor">
-            <a:schemeClr val="lt1"/>
-          </a:fontRef>
-        </p:style>
-        <p:txBody>
-          <a:bodyPr rtlCol="0" anchor="ctr"/>
-          <a:lstStyle/>
-          <a:p>
-            <a:pPr algn="ctr"/>
-          </a:p>
-        </p:txBody>
-      </p:sp>
-      <p:sp>
-        <p:nvSpPr>
-          <p:cNvPr id="29" name="TextBox 28"/>
-          <p:cNvSpPr txBox="1"/>
-          <p:nvPr/>
-        </p:nvSpPr>
-        <p:spPr>
-          <a:xfrm>
-            <a:off x="795528" y="5797296"/>
-            <a:ext cx="10607040" cy="320040"/>
-          </a:xfrm>
-          <a:prstGeom prst="rect">
-            <a:avLst/>
-          </a:prstGeom>
-          <a:noFill/>
-        </p:spPr>
-        <p:txBody>
-          <a:bodyPr wrap="square" lIns="0" rIns="0" tIns="0" bIns="0">
-            <a:spAutoFit/>
-          </a:bodyPr>
-          <a:lstStyle/>
-          <a:p>
-            <a:pPr algn="l">
-              <a:lnSpc>
-                <a:spcPct val="116000"/>
-              </a:lnSpc>
-              <a:spcBef>
-                <a:spcPts val="0"/>
-              </a:spcBef>
-              <a:spcAft>
-                <a:spcPts val="100"/>
-              </a:spcAft>
-            </a:pPr>
-            <a:r>
-              <a:rPr sz="2000" b="1" lang="ko-KR">
-                <a:solidFill>
-                  <a:srgbClr val="FFFFFF"/>
-                </a:solidFill>
-                <a:latin typeface="맑은 고딕"/>
-                <a:ea typeface="맑은 고딕"/>
-              </a:rPr>
-              <a:t>제조원가율(%) = 1T당 제조원가 ÷ 약가 × 100</a:t>
-            </a:r>
-          </a:p>
-        </p:txBody>
-      </p:sp>
-      <p:sp>
-        <p:nvSpPr>
-          <p:cNvPr id="30" name="TextBox 29"/>
-          <p:cNvSpPr txBox="1"/>
-          <p:nvPr/>
-        </p:nvSpPr>
-        <p:spPr>
-          <a:xfrm>
-            <a:off x="594360" y="6373368"/>
-            <a:ext cx="10972800" cy="155448"/>
-          </a:xfrm>
-          <a:prstGeom prst="rect">
-            <a:avLst/>
-          </a:prstGeom>
-          <a:noFill/>
-        </p:spPr>
-        <p:txBody>
-          <a:bodyPr wrap="square" lIns="0" rIns="0" tIns="0" bIns="0">
-            <a:spAutoFit/>
-          </a:bodyPr>
-          <a:lstStyle/>
-          <a:p>
-            <a:pPr algn="l">
-              <a:lnSpc>
-                <a:spcPct val="116000"/>
-              </a:lnSpc>
-              <a:spcBef>
-                <a:spcPts val="0"/>
-              </a:spcBef>
-              <a:spcAft>
-                <a:spcPts val="100"/>
-              </a:spcAft>
-            </a:pPr>
-            <a:r>
-              <a:rPr sz="910" b="0" lang="ko-KR">
-                <a:solidFill>
-                  <a:srgbClr val="637F8D"/>
-                </a:solidFill>
-                <a:latin typeface="맑은 고딕"/>
-                <a:ea typeface="맑은 고딕"/>
-              </a:rPr>
-              <a:t>T는 정·캡슐 등 단위제형입니다. 수율은 모든 1T 비용에 반영하며, 예상 약가의 일반·수급안정 가산은 간편 가정입니다.</a:t>
+              <a:t>직접 입력 모드에서는 회사·품목·시장 조건이 비활성화됩니다. 예상 약가의 일반·수급안정 가산은 간편 가정입니다.</a:t>
             </a:r>
           </a:p>
         </p:txBody>
@@ -5091,7 +5007,7 @@
                 <a:latin typeface="맑은 고딕"/>
                 <a:ea typeface="맑은 고딕"/>
               </a:rPr>
-              <a:t>HOW TO USE</a:t>
+              <a:t>02  INPUT · COST ITEMS</a:t>
             </a:r>
           </a:p>
         </p:txBody>
@@ -5183,7 +5099,7 @@
                 <a:latin typeface="맑은 고딕"/>
                 <a:ea typeface="맑은 고딕"/>
               </a:rPr>
-              <a:t>입력부터 비교까지, 4단계로 사용합니다</a:t>
+              <a:t>원료와 배치 전체 고정비를 입력합니다</a:t>
             </a:r>
           </a:p>
         </p:txBody>
@@ -5229,7 +5145,7 @@
                 <a:latin typeface="맑은 고딕"/>
                 <a:ea typeface="맑은 고딕"/>
               </a:rPr>
-              <a:t>조건을 바꾸면 원가율과 연차별 예상이익이 즉시 갱신됩니다.</a:t>
+              <a:t>원료표는 행 단위로 편집하고, 입력값을 바꾸면 배치당·1T당 비용이 바로 갱신됩니다.</a:t>
             </a:r>
           </a:p>
         </p:txBody>
@@ -5322,27 +5238,51 @@
                 <a:latin typeface="맑은 고딕"/>
                 <a:ea typeface="맑은 고딕"/>
               </a:rPr>
-              <a:t>02 / 02</a:t>
-            </a:r>
-          </a:p>
-        </p:txBody>
-      </p:sp>
-      <p:sp>
-        <p:nvSpPr>
-          <p:cNvPr id="9" name="Rectangle 8"/>
+              <a:t>02 / 05</a:t>
+            </a:r>
+          </a:p>
+        </p:txBody>
+      </p:sp>
+      <p:pic>
+        <p:nvPicPr>
+          <p:cNvPr id="9" name="Picture 8" descr="input-materials.png"/>
+          <p:cNvPicPr>
+            <a:picLocks noChangeAspect="1"/>
+          </p:cNvPicPr>
+          <p:nvPr/>
+        </p:nvPicPr>
+        <p:blipFill>
+          <a:blip r:embed="rId3"/>
+          <a:stretch>
+            <a:fillRect/>
+          </a:stretch>
+        </p:blipFill>
+        <p:spPr>
+          <a:xfrm>
+            <a:off x="566928" y="1810512"/>
+            <a:ext cx="11055096" cy="3457230"/>
+          </a:xfrm>
+          <a:prstGeom prst="rect">
+            <a:avLst/>
+          </a:prstGeom>
+        </p:spPr>
+      </p:pic>
+      <p:sp>
+        <p:nvSpPr>
+          <p:cNvPr id="10" name="Oval 9"/>
           <p:cNvSpPr/>
           <p:nvPr/>
         </p:nvSpPr>
         <p:spPr>
           <a:xfrm>
-            <a:off x="737006" y="2084831"/>
-            <a:ext cx="14630" cy="3246120"/>
-          </a:xfrm>
-          <a:prstGeom prst="rect">
+            <a:off x="594360" y="5477256"/>
+            <a:ext cx="320040" cy="320040"/>
+          </a:xfrm>
+          <a:prstGeom prst="ellipse">
             <a:avLst/>
           </a:prstGeom>
           <a:solidFill>
-            <a:srgbClr val="D9E5E8"/>
+            <a:srgbClr val="E7F4F2"/>
           </a:solidFill>
           <a:ln>
             <a:noFill/>
@@ -5363,22 +5303,146 @@
           </a:fontRef>
         </p:style>
         <p:txBody>
-          <a:bodyPr rtlCol="0" anchor="ctr"/>
+          <a:bodyPr rtlCol="0" anchor="ctr" lIns="0" rIns="0" tIns="0" bIns="0"/>
           <a:lstStyle/>
           <a:p>
             <a:pPr algn="ctr"/>
-          </a:p>
-        </p:txBody>
-      </p:sp>
-      <p:sp>
-        <p:nvSpPr>
-          <p:cNvPr id="10" name="Oval 9"/>
+            <a:r>
+              <a:rPr sz="1100" b="1">
+                <a:solidFill>
+                  <a:srgbClr val="087F82"/>
+                </a:solidFill>
+                <a:latin typeface="맑은 고딕"/>
+              </a:rPr>
+              <a:t>01</a:t>
+            </a:r>
+          </a:p>
+        </p:txBody>
+      </p:sp>
+      <p:sp>
+        <p:nvSpPr>
+          <p:cNvPr id="11" name="TextBox 10"/>
+          <p:cNvSpPr txBox="1"/>
+          <p:nvPr/>
+        </p:nvSpPr>
+        <p:spPr>
+          <a:xfrm>
+            <a:off x="1024128" y="5463540"/>
+            <a:ext cx="3044952" cy="301752"/>
+          </a:xfrm>
+          <a:prstGeom prst="rect">
+            <a:avLst/>
+          </a:prstGeom>
+          <a:noFill/>
+        </p:spPr>
+        <p:txBody>
+          <a:bodyPr wrap="square" lIns="0" rIns="0" tIns="0" bIns="0">
+            <a:spAutoFit/>
+          </a:bodyPr>
+          <a:lstStyle/>
+          <a:p>
+            <a:pPr algn="l">
+              <a:lnSpc>
+                <a:spcPct val="116000"/>
+              </a:lnSpc>
+              <a:spcBef>
+                <a:spcPts val="0"/>
+              </a:spcBef>
+              <a:spcAft>
+                <a:spcPts val="100"/>
+              </a:spcAft>
+            </a:pPr>
+            <a:r>
+              <a:rPr sz="1520" b="1" lang="ko-KR">
+                <a:solidFill>
+                  <a:srgbClr val="153C4D"/>
+                </a:solidFill>
+                <a:latin typeface="맑은 고딕"/>
+                <a:ea typeface="맑은 고딕"/>
+              </a:rPr>
+              <a:t>실제 투입량 입력</a:t>
+            </a:r>
+          </a:p>
+        </p:txBody>
+      </p:sp>
+      <p:sp>
+        <p:nvSpPr>
+          <p:cNvPr id="12" name="TextBox 11"/>
+          <p:cNvSpPr txBox="1"/>
+          <p:nvPr/>
+        </p:nvSpPr>
+        <p:spPr>
+          <a:xfrm>
+            <a:off x="1024128" y="5833872"/>
+            <a:ext cx="3044952" cy="640080"/>
+          </a:xfrm>
+          <a:prstGeom prst="rect">
+            <a:avLst/>
+          </a:prstGeom>
+          <a:noFill/>
+        </p:spPr>
+        <p:txBody>
+          <a:bodyPr wrap="square" lIns="0" rIns="0" tIns="0" bIns="0">
+            <a:spAutoFit/>
+          </a:bodyPr>
+          <a:lstStyle/>
+          <a:p>
+            <a:pPr algn="l">
+              <a:lnSpc>
+                <a:spcPct val="116000"/>
+              </a:lnSpc>
+              <a:spcBef>
+                <a:spcPts val="0"/>
+              </a:spcBef>
+              <a:spcAft>
+                <a:spcPts val="100"/>
+              </a:spcAft>
+            </a:pPr>
+            <a:r>
+              <a:rPr sz="1250" b="0" lang="ko-KR">
+                <a:solidFill>
+                  <a:srgbClr val="637F8D"/>
+                </a:solidFill>
+                <a:latin typeface="맑은 고딕"/>
+                <a:ea typeface="맑은 고딕"/>
+              </a:rPr>
+              <a:t>API·부형제를 추가하고</a:t>
+            </a:r>
+          </a:p>
+          <a:p>
+            <a:pPr algn="l">
+              <a:lnSpc>
+                <a:spcPct val="116000"/>
+              </a:lnSpc>
+              <a:spcBef>
+                <a:spcPts val="0"/>
+              </a:spcBef>
+              <a:spcAft>
+                <a:spcPts val="100"/>
+              </a:spcAft>
+            </a:pPr>
+            <a:r>
+              <a:rPr sz="1250" b="0" lang="ko-KR">
+                <a:solidFill>
+                  <a:srgbClr val="637F8D"/>
+                </a:solidFill>
+                <a:latin typeface="맑은 고딕"/>
+                <a:ea typeface="맑은 고딕"/>
+              </a:rPr>
+              <a:t>1T당 투입량을 mg로 입력</a:t>
+            </a:r>
+          </a:p>
+        </p:txBody>
+      </p:sp>
+      <p:sp>
+        <p:nvSpPr>
+          <p:cNvPr id="13" name="Oval 12"/>
           <p:cNvSpPr/>
           <p:nvPr/>
         </p:nvSpPr>
         <p:spPr>
           <a:xfrm>
-            <a:off x="585216" y="1938528"/>
+            <a:off x="4361688" y="5477256"/>
             <a:ext cx="320040" cy="320040"/>
           </a:xfrm>
           <a:prstGeom prst="ellipse">
@@ -5417,21 +5481,21 @@
                 </a:solidFill>
                 <a:latin typeface="맑은 고딕"/>
               </a:rPr>
-              <a:t>01</a:t>
-            </a:r>
-          </a:p>
-        </p:txBody>
-      </p:sp>
-      <p:sp>
-        <p:nvSpPr>
-          <p:cNvPr id="11" name="TextBox 10"/>
+              <a:t>02</a:t>
+            </a:r>
+          </a:p>
+        </p:txBody>
+      </p:sp>
+      <p:sp>
+        <p:nvSpPr>
+          <p:cNvPr id="14" name="TextBox 13"/>
           <p:cNvSpPr txBox="1"/>
           <p:nvPr/>
         </p:nvSpPr>
         <p:spPr>
           <a:xfrm>
-            <a:off x="1051560" y="1929384"/>
-            <a:ext cx="3749039" cy="292608"/>
+            <a:off x="4791455" y="5463540"/>
+            <a:ext cx="3044952" cy="301752"/>
           </a:xfrm>
           <a:prstGeom prst="rect">
             <a:avLst/>
@@ -5456,28 +5520,28 @@
               </a:spcAft>
             </a:pPr>
             <a:r>
-              <a:rPr sz="1660" b="1" lang="ko-KR">
+              <a:rPr sz="1520" b="1" lang="ko-KR">
                 <a:solidFill>
                   <a:srgbClr val="153C4D"/>
                 </a:solidFill>
                 <a:latin typeface="맑은 고딕"/>
                 <a:ea typeface="맑은 고딕"/>
               </a:rPr>
-              <a:t>새 프로젝트 · 생산조건</a:t>
-            </a:r>
-          </a:p>
-        </p:txBody>
-      </p:sp>
-      <p:sp>
-        <p:nvSpPr>
-          <p:cNvPr id="12" name="TextBox 11"/>
+              <a:t>구매단가·단위 선택</a:t>
+            </a:r>
+          </a:p>
+        </p:txBody>
+      </p:sp>
+      <p:sp>
+        <p:nvSpPr>
+          <p:cNvPr id="15" name="TextBox 14"/>
           <p:cNvSpPr txBox="1"/>
           <p:nvPr/>
         </p:nvSpPr>
         <p:spPr>
           <a:xfrm>
-            <a:off x="1051560" y="2267712"/>
-            <a:ext cx="3694176" cy="548640"/>
+            <a:off x="4791455" y="5833872"/>
+            <a:ext cx="3044952" cy="640080"/>
           </a:xfrm>
           <a:prstGeom prst="rect">
             <a:avLst/>
@@ -5502,14 +5566,14 @@
               </a:spcAft>
             </a:pPr>
             <a:r>
-              <a:rPr sz="1290" b="0" lang="ko-KR">
+              <a:rPr sz="1250" b="0" lang="ko-KR">
                 <a:solidFill>
                   <a:srgbClr val="637F8D"/>
                 </a:solidFill>
                 <a:latin typeface="맑은 고딕"/>
                 <a:ea typeface="맑은 고딕"/>
               </a:rPr>
-              <a:t>제품명·비고를 시나리오별로 입력.</a:t>
+              <a:t>원/g·원/kg·달러/g·달러/kg</a:t>
             </a:r>
           </a:p>
           <a:p>
@@ -5525,27 +5589,27 @@
               </a:spcAft>
             </a:pPr>
             <a:r>
-              <a:rPr sz="1290" b="0" lang="ko-KR">
+              <a:rPr sz="1250" b="0" lang="ko-KR">
                 <a:solidFill>
                   <a:srgbClr val="637F8D"/>
                 </a:solidFill>
                 <a:latin typeface="맑은 고딕"/>
                 <a:ea typeface="맑은 고딕"/>
               </a:rPr>
-              <a:t>배치·수율·포장형태·환율 설정</a:t>
-            </a:r>
-          </a:p>
-        </p:txBody>
-      </p:sp>
-      <p:sp>
-        <p:nvSpPr>
-          <p:cNvPr id="13" name="Oval 12"/>
+              <a:t>달러 단가는 입력 환율로 환산</a:t>
+            </a:r>
+          </a:p>
+        </p:txBody>
+      </p:sp>
+      <p:sp>
+        <p:nvSpPr>
+          <p:cNvPr id="16" name="Oval 15"/>
           <p:cNvSpPr/>
           <p:nvPr/>
         </p:nvSpPr>
         <p:spPr>
           <a:xfrm>
-            <a:off x="585216" y="2880360"/>
+            <a:off x="8129016" y="5477256"/>
             <a:ext cx="320040" cy="320040"/>
           </a:xfrm>
           <a:prstGeom prst="ellipse">
@@ -5584,21 +5648,21 @@
                 </a:solidFill>
                 <a:latin typeface="맑은 고딕"/>
               </a:rPr>
-              <a:t>02</a:t>
-            </a:r>
-          </a:p>
-        </p:txBody>
-      </p:sp>
-      <p:sp>
-        <p:nvSpPr>
-          <p:cNvPr id="14" name="TextBox 13"/>
+              <a:t>03</a:t>
+            </a:r>
+          </a:p>
+        </p:txBody>
+      </p:sp>
+      <p:sp>
+        <p:nvSpPr>
+          <p:cNvPr id="17" name="TextBox 16"/>
           <p:cNvSpPr txBox="1"/>
           <p:nvPr/>
         </p:nvSpPr>
         <p:spPr>
           <a:xfrm>
-            <a:off x="1051560" y="2871216"/>
-            <a:ext cx="3749039" cy="292608"/>
+            <a:off x="8558784" y="5463540"/>
+            <a:ext cx="3044952" cy="301752"/>
           </a:xfrm>
           <a:prstGeom prst="rect">
             <a:avLst/>
@@ -5623,28 +5687,28 @@
               </a:spcAft>
             </a:pPr>
             <a:r>
-              <a:rPr sz="1660" b="1" lang="ko-KR">
+              <a:rPr sz="1520" b="1" lang="ko-KR">
                 <a:solidFill>
                   <a:srgbClr val="153C4D"/>
                 </a:solidFill>
                 <a:latin typeface="맑은 고딕"/>
                 <a:ea typeface="맑은 고딕"/>
               </a:rPr>
-              <a:t>약가 · 원가 입력</a:t>
-            </a:r>
-          </a:p>
-        </p:txBody>
-      </p:sp>
-      <p:sp>
-        <p:nvSpPr>
-          <p:cNvPr id="15" name="TextBox 14"/>
+              <a:t>고정비는 배치 전체 금액</a:t>
+            </a:r>
+          </a:p>
+        </p:txBody>
+      </p:sp>
+      <p:sp>
+        <p:nvSpPr>
+          <p:cNvPr id="18" name="TextBox 17"/>
           <p:cNvSpPr txBox="1"/>
           <p:nvPr/>
         </p:nvSpPr>
         <p:spPr>
           <a:xfrm>
-            <a:off x="1051560" y="3209544"/>
-            <a:ext cx="3694176" cy="548640"/>
+            <a:off x="8558784" y="5833872"/>
+            <a:ext cx="3044952" cy="640080"/>
           </a:xfrm>
           <a:prstGeom prst="rect">
             <a:avLst/>
@@ -5669,14 +5733,14 @@
               </a:spcAft>
             </a:pPr>
             <a:r>
-              <a:rPr sz="1290" b="0" lang="ko-KR">
+              <a:rPr sz="1250" b="0" lang="ko-KR">
                 <a:solidFill>
                   <a:srgbClr val="637F8D"/>
                 </a:solidFill>
                 <a:latin typeface="맑은 고딕"/>
                 <a:ea typeface="맑은 고딕"/>
               </a:rPr>
-              <a:t>약가 모드·원료 투입량(mg/T)·단가,</a:t>
+              <a:t>포자재비·공수비를 입력하면</a:t>
             </a:r>
           </a:p>
           <a:p>
@@ -5692,34 +5756,106 @@
               </a:spcAft>
             </a:pPr>
             <a:r>
-              <a:rPr sz="1290" b="0" lang="ko-KR">
+              <a:rPr sz="1250" b="0" lang="ko-KR">
                 <a:solidFill>
                   <a:srgbClr val="637F8D"/>
                 </a:solidFill>
                 <a:latin typeface="맑은 고딕"/>
                 <a:ea typeface="맑은 고딕"/>
               </a:rPr>
-              <a:t>배치 전체 포자재비·공수비 입력</a:t>
-            </a:r>
-          </a:p>
-        </p:txBody>
-      </p:sp>
-      <p:sp>
-        <p:nvSpPr>
-          <p:cNvPr id="16" name="Oval 15"/>
+              <a:t>수율을 반영한 1T당 비용 계산</a:t>
+            </a:r>
+          </a:p>
+        </p:txBody>
+      </p:sp>
+      <p:sp>
+        <p:nvSpPr>
+          <p:cNvPr id="19" name="TextBox 18"/>
+          <p:cNvSpPr txBox="1"/>
+          <p:nvPr/>
+        </p:nvSpPr>
+        <p:spPr>
+          <a:xfrm>
+            <a:off x="594360" y="6373368"/>
+            <a:ext cx="10972800" cy="155448"/>
+          </a:xfrm>
+          <a:prstGeom prst="rect">
+            <a:avLst/>
+          </a:prstGeom>
+          <a:noFill/>
+        </p:spPr>
+        <p:txBody>
+          <a:bodyPr wrap="square" lIns="0" rIns="0" tIns="0" bIns="0">
+            <a:spAutoFit/>
+          </a:bodyPr>
+          <a:lstStyle/>
+          <a:p>
+            <a:pPr algn="l">
+              <a:lnSpc>
+                <a:spcPct val="116000"/>
+              </a:lnSpc>
+              <a:spcBef>
+                <a:spcPts val="0"/>
+              </a:spcBef>
+              <a:spcAft>
+                <a:spcPts val="100"/>
+              </a:spcAft>
+            </a:pPr>
+            <a:r>
+              <a:rPr sz="890" b="0" lang="ko-KR">
+                <a:solidFill>
+                  <a:srgbClr val="637F8D"/>
+                </a:solidFill>
+                <a:latin typeface="맑은 고딕"/>
+                <a:ea typeface="맑은 고딕"/>
+              </a:rPr>
+              <a:t>수율은 배치 전체 비용을 1T당 비용으로 환산할 때 반영합니다. 표시 함량이 아닌 실제 원료 투입량으로 계산합니다.</a:t>
+            </a:r>
+          </a:p>
+        </p:txBody>
+      </p:sp>
+    </p:spTree>
+  </p:cSld>
+  <p:clrMapOvr>
+    <a:masterClrMapping/>
+  </p:clrMapOvr>
+</p:sld>
+</file>
+
+<file path=ppt/slides/slide3.xml><?xml version="1.0" encoding="utf-8"?>
+<p:sld xmlns:a="http://schemas.openxmlformats.org/drawingml/2006/main" xmlns:p="http://schemas.openxmlformats.org/presentationml/2006/main" xmlns:r="http://schemas.openxmlformats.org/officeDocument/2006/relationships">
+  <p:cSld>
+    <p:bg>
+      <p:bgPr>
+        <a:solidFill>
+          <a:srgbClr val="F4F8F9"/>
+        </a:solidFill>
+        <a:effectLst/>
+      </p:bgPr>
+    </p:bg>
+    <p:spTree>
+      <p:nvGrpSpPr>
+        <p:cNvPr id="1" name=""/>
+        <p:cNvGrpSpPr/>
+        <p:nvPr/>
+      </p:nvGrpSpPr>
+      <p:grpSpPr/>
+      <p:sp>
+        <p:nvSpPr>
+          <p:cNvPr id="2" name="Rectangle 1"/>
           <p:cNvSpPr/>
           <p:nvPr/>
         </p:nvSpPr>
         <p:spPr>
           <a:xfrm>
-            <a:off x="585216" y="3822191"/>
-            <a:ext cx="320040" cy="320040"/>
-          </a:xfrm>
-          <a:prstGeom prst="ellipse">
+            <a:off x="0" y="0"/>
+            <a:ext cx="12191695" cy="59436"/>
+          </a:xfrm>
+          <a:prstGeom prst="rect">
             <a:avLst/>
           </a:prstGeom>
           <a:solidFill>
-            <a:srgbClr val="E7F4F2"/>
+            <a:srgbClr val="087F82"/>
           </a:solidFill>
           <a:ln>
             <a:noFill/>
@@ -5740,32 +5876,23 @@
           </a:fontRef>
         </p:style>
         <p:txBody>
-          <a:bodyPr rtlCol="0" anchor="ctr" lIns="0" rIns="0" tIns="0" bIns="0"/>
+          <a:bodyPr rtlCol="0" anchor="ctr"/>
           <a:lstStyle/>
           <a:p>
             <a:pPr algn="ctr"/>
-            <a:r>
-              <a:rPr sz="1100" b="1">
-                <a:solidFill>
-                  <a:srgbClr val="087F82"/>
-                </a:solidFill>
-                <a:latin typeface="맑은 고딕"/>
-              </a:rPr>
-              <a:t>03</a:t>
-            </a:r>
-          </a:p>
-        </p:txBody>
-      </p:sp>
-      <p:sp>
-        <p:nvSpPr>
-          <p:cNvPr id="17" name="TextBox 16"/>
+          </a:p>
+        </p:txBody>
+      </p:sp>
+      <p:sp>
+        <p:nvSpPr>
+          <p:cNvPr id="3" name="TextBox 2"/>
           <p:cNvSpPr txBox="1"/>
           <p:nvPr/>
         </p:nvSpPr>
         <p:spPr>
           <a:xfrm>
-            <a:off x="1051560" y="3813048"/>
-            <a:ext cx="3749039" cy="292608"/>
+            <a:off x="566928" y="338328"/>
+            <a:ext cx="7315200" cy="182880"/>
           </a:xfrm>
           <a:prstGeom prst="rect">
             <a:avLst/>
@@ -5790,28 +5917,74 @@
               </a:spcAft>
             </a:pPr>
             <a:r>
-              <a:rPr sz="1660" b="1" lang="ko-KR">
-                <a:solidFill>
-                  <a:srgbClr val="153C4D"/>
+              <a:rPr sz="1050" b="1" lang="ko-KR">
+                <a:solidFill>
+                  <a:srgbClr val="087F82"/>
                 </a:solidFill>
                 <a:latin typeface="맑은 고딕"/>
                 <a:ea typeface="맑은 고딕"/>
               </a:rPr>
-              <a:t>결과 확인 · 시나리오 비교</a:t>
-            </a:r>
-          </a:p>
-        </p:txBody>
-      </p:sp>
-      <p:sp>
-        <p:nvSpPr>
-          <p:cNvPr id="18" name="TextBox 17"/>
+              <a:t>03  RESULTS</a:t>
+            </a:r>
+          </a:p>
+        </p:txBody>
+      </p:sp>
+      <p:sp>
+        <p:nvSpPr>
+          <p:cNvPr id="4" name="TextBox 3"/>
           <p:cNvSpPr txBox="1"/>
           <p:nvPr/>
         </p:nvSpPr>
         <p:spPr>
           <a:xfrm>
-            <a:off x="1051560" y="4151376"/>
-            <a:ext cx="3694176" cy="548640"/>
+            <a:off x="10744200" y="338328"/>
+            <a:ext cx="877824" cy="182880"/>
+          </a:xfrm>
+          <a:prstGeom prst="rect">
+            <a:avLst/>
+          </a:prstGeom>
+          <a:noFill/>
+        </p:spPr>
+        <p:txBody>
+          <a:bodyPr wrap="square" lIns="0" rIns="0" tIns="0" bIns="0">
+            <a:spAutoFit/>
+          </a:bodyPr>
+          <a:lstStyle/>
+          <a:p>
+            <a:pPr algn="r">
+              <a:lnSpc>
+                <a:spcPct val="116000"/>
+              </a:lnSpc>
+              <a:spcBef>
+                <a:spcPts val="0"/>
+              </a:spcBef>
+              <a:spcAft>
+                <a:spcPts val="100"/>
+              </a:spcAft>
+            </a:pPr>
+            <a:r>
+              <a:rPr sz="1000" b="0" lang="ko-KR">
+                <a:solidFill>
+                  <a:srgbClr val="637F8D"/>
+                </a:solidFill>
+                <a:latin typeface="맑은 고딕"/>
+                <a:ea typeface="맑은 고딕"/>
+              </a:rPr>
+              <a:t>2026.10</a:t>
+            </a:r>
+          </a:p>
+        </p:txBody>
+      </p:sp>
+      <p:sp>
+        <p:nvSpPr>
+          <p:cNvPr id="5" name="TextBox 4"/>
+          <p:cNvSpPr txBox="1"/>
+          <p:nvPr/>
+        </p:nvSpPr>
+        <p:spPr>
+          <a:xfrm>
+            <a:off x="566928" y="694944"/>
+            <a:ext cx="11064240" cy="484632"/>
           </a:xfrm>
           <a:prstGeom prst="rect">
             <a:avLst/>
@@ -5836,16 +6009,39 @@
               </a:spcAft>
             </a:pPr>
             <a:r>
-              <a:rPr sz="1290" b="0" lang="ko-KR">
-                <a:solidFill>
-                  <a:srgbClr val="637F8D"/>
+              <a:rPr sz="2900" b="1" lang="ko-KR">
+                <a:solidFill>
+                  <a:srgbClr val="153C4D"/>
                 </a:solidFill>
                 <a:latin typeface="맑은 고딕"/>
                 <a:ea typeface="맑은 고딕"/>
               </a:rPr>
-              <a:t>‘현재 입력 복제’ 후 조건 변경.</a:t>
-            </a:r>
-          </a:p>
+              <a:t>결과 탭에서 제조원가율을 확인합니다</a:t>
+            </a:r>
+          </a:p>
+        </p:txBody>
+      </p:sp>
+      <p:sp>
+        <p:nvSpPr>
+          <p:cNvPr id="6" name="TextBox 5"/>
+          <p:cNvSpPr txBox="1"/>
+          <p:nvPr/>
+        </p:nvSpPr>
+        <p:spPr>
+          <a:xfrm>
+            <a:off x="585216" y="1271016"/>
+            <a:ext cx="10972800" cy="329184"/>
+          </a:xfrm>
+          <a:prstGeom prst="rect">
+            <a:avLst/>
+          </a:prstGeom>
+          <a:noFill/>
+        </p:spPr>
+        <p:txBody>
+          <a:bodyPr wrap="square" lIns="0" rIns="0" tIns="0" bIns="0">
+            <a:spAutoFit/>
+          </a:bodyPr>
+          <a:lstStyle/>
           <a:p>
             <a:pPr algn="l">
               <a:lnSpc>
@@ -5859,31 +6055,150 @@
               </a:spcAft>
             </a:pPr>
             <a:r>
-              <a:rPr sz="1290" b="0" lang="ko-KR">
+              <a:rPr sz="1610" b="0" lang="ko-KR">
                 <a:solidFill>
                   <a:srgbClr val="637F8D"/>
                 </a:solidFill>
                 <a:latin typeface="맑은 고딕"/>
                 <a:ea typeface="맑은 고딕"/>
               </a:rPr>
-              <a:t>결과·비교 탭에서 최대 4개 안 비교</a:t>
-            </a:r>
-          </a:p>
-        </p:txBody>
-      </p:sp>
-      <p:sp>
-        <p:nvSpPr>
-          <p:cNvPr id="19" name="Oval 18"/>
+              <a:t>왼쪽은 비용 구성, 오른쪽은 약가 → 제조원가 → 원가율입니다. 핵심 지표인 원가율을 강조합니다.</a:t>
+            </a:r>
+          </a:p>
+        </p:txBody>
+      </p:sp>
+      <p:sp>
+        <p:nvSpPr>
+          <p:cNvPr id="7" name="TextBox 6"/>
+          <p:cNvSpPr txBox="1"/>
+          <p:nvPr/>
+        </p:nvSpPr>
+        <p:spPr>
+          <a:xfrm>
+            <a:off x="566928" y="6565392"/>
+            <a:ext cx="4937760" cy="164592"/>
+          </a:xfrm>
+          <a:prstGeom prst="rect">
+            <a:avLst/>
+          </a:prstGeom>
+          <a:noFill/>
+        </p:spPr>
+        <p:txBody>
+          <a:bodyPr wrap="square" lIns="0" rIns="0" tIns="0" bIns="0">
+            <a:spAutoFit/>
+          </a:bodyPr>
+          <a:lstStyle/>
+          <a:p>
+            <a:pPr algn="l">
+              <a:lnSpc>
+                <a:spcPct val="116000"/>
+              </a:lnSpc>
+              <a:spcBef>
+                <a:spcPts val="0"/>
+              </a:spcBef>
+              <a:spcAft>
+                <a:spcPts val="100"/>
+              </a:spcAft>
+            </a:pPr>
+            <a:r>
+              <a:rPr sz="919" b="0" lang="ko-KR">
+                <a:solidFill>
+                  <a:srgbClr val="087F82"/>
+                </a:solidFill>
+                <a:latin typeface="맑은 고딕"/>
+                <a:ea typeface="맑은 고딕"/>
+                <a:hlinkClick r:id="rId2"/>
+              </a:rPr>
+              <a:t>https://smoothsea45.github.io/project1/</a:t>
+            </a:r>
+          </a:p>
+        </p:txBody>
+      </p:sp>
+      <p:sp>
+        <p:nvSpPr>
+          <p:cNvPr id="8" name="TextBox 7"/>
+          <p:cNvSpPr txBox="1"/>
+          <p:nvPr/>
+        </p:nvSpPr>
+        <p:spPr>
+          <a:xfrm>
+            <a:off x="11064240" y="6565392"/>
+            <a:ext cx="548640" cy="164592"/>
+          </a:xfrm>
+          <a:prstGeom prst="rect">
+            <a:avLst/>
+          </a:prstGeom>
+          <a:noFill/>
+        </p:spPr>
+        <p:txBody>
+          <a:bodyPr wrap="square" lIns="0" rIns="0" tIns="0" bIns="0">
+            <a:spAutoFit/>
+          </a:bodyPr>
+          <a:lstStyle/>
+          <a:p>
+            <a:pPr algn="r">
+              <a:lnSpc>
+                <a:spcPct val="116000"/>
+              </a:lnSpc>
+              <a:spcBef>
+                <a:spcPts val="0"/>
+              </a:spcBef>
+              <a:spcAft>
+                <a:spcPts val="100"/>
+              </a:spcAft>
+            </a:pPr>
+            <a:r>
+              <a:rPr sz="919" b="0" lang="ko-KR">
+                <a:solidFill>
+                  <a:srgbClr val="637F8D"/>
+                </a:solidFill>
+                <a:latin typeface="맑은 고딕"/>
+                <a:ea typeface="맑은 고딕"/>
+              </a:rPr>
+              <a:t>03 / 05</a:t>
+            </a:r>
+          </a:p>
+        </p:txBody>
+      </p:sp>
+      <p:pic>
+        <p:nvPicPr>
+          <p:cNvPr id="9" name="Picture 8" descr="results.png"/>
+          <p:cNvPicPr>
+            <a:picLocks noChangeAspect="1"/>
+          </p:cNvPicPr>
+          <p:nvPr/>
+        </p:nvPicPr>
+        <p:blipFill>
+          <a:blip r:embed="rId3"/>
+          <a:stretch>
+            <a:fillRect/>
+          </a:stretch>
+        </p:blipFill>
+        <p:spPr>
+          <a:xfrm>
+            <a:off x="566928" y="1810512"/>
+            <a:ext cx="11055096" cy="4301437"/>
+          </a:xfrm>
+          <a:prstGeom prst="rect">
+            <a:avLst/>
+          </a:prstGeom>
+        </p:spPr>
+      </p:pic>
+      <p:sp>
+        <p:nvSpPr>
+          <p:cNvPr id="10" name="Rounded Rectangle 9"/>
           <p:cNvSpPr/>
           <p:nvPr/>
         </p:nvSpPr>
         <p:spPr>
           <a:xfrm>
-            <a:off x="585216" y="4764024"/>
-            <a:ext cx="320040" cy="320040"/>
-          </a:xfrm>
-          <a:prstGeom prst="ellipse">
-            <a:avLst/>
+            <a:off x="566928" y="6208776"/>
+            <a:ext cx="11055096" cy="265176"/>
+          </a:xfrm>
+          <a:prstGeom prst="roundRect">
+            <a:avLst>
+              <a:gd name="adj" fmla="val 12000"/>
+            </a:avLst>
           </a:prstGeom>
           <a:solidFill>
             <a:srgbClr val="E7F4F2"/>
@@ -5907,32 +6222,23 @@
           </a:fontRef>
         </p:style>
         <p:txBody>
-          <a:bodyPr rtlCol="0" anchor="ctr" lIns="0" rIns="0" tIns="0" bIns="0"/>
+          <a:bodyPr rtlCol="0" anchor="ctr"/>
           <a:lstStyle/>
           <a:p>
             <a:pPr algn="ctr"/>
-            <a:r>
-              <a:rPr sz="1100" b="1">
-                <a:solidFill>
-                  <a:srgbClr val="087F82"/>
-                </a:solidFill>
-                <a:latin typeface="맑은 고딕"/>
-              </a:rPr>
-              <a:t>04</a:t>
-            </a:r>
-          </a:p>
-        </p:txBody>
-      </p:sp>
-      <p:sp>
-        <p:nvSpPr>
-          <p:cNvPr id="20" name="TextBox 19"/>
+          </a:p>
+        </p:txBody>
+      </p:sp>
+      <p:sp>
+        <p:nvSpPr>
+          <p:cNvPr id="11" name="TextBox 10"/>
           <p:cNvSpPr txBox="1"/>
           <p:nvPr/>
         </p:nvSpPr>
         <p:spPr>
           <a:xfrm>
-            <a:off x="1051560" y="4754880"/>
-            <a:ext cx="3749039" cy="292608"/>
+            <a:off x="722376" y="6222492"/>
+            <a:ext cx="10744200" cy="201168"/>
           </a:xfrm>
           <a:prstGeom prst="rect">
             <a:avLst/>
@@ -5957,148 +6263,57 @@
               </a:spcAft>
             </a:pPr>
             <a:r>
-              <a:rPr sz="1660" b="1" lang="ko-KR">
-                <a:solidFill>
-                  <a:srgbClr val="153C4D"/>
+              <a:rPr sz="1280" b="1" lang="ko-KR">
+                <a:solidFill>
+                  <a:srgbClr val="087F82"/>
                 </a:solidFill>
                 <a:latin typeface="맑은 고딕"/>
                 <a:ea typeface="맑은 고딕"/>
               </a:rPr>
-              <a:t>SF · 이익 분석 (선택)</a:t>
-            </a:r>
-          </a:p>
-        </p:txBody>
-      </p:sp>
-      <p:sp>
-        <p:nvSpPr>
-          <p:cNvPr id="21" name="TextBox 20"/>
-          <p:cNvSpPr txBox="1"/>
-          <p:nvPr/>
-        </p:nvSpPr>
-        <p:spPr>
-          <a:xfrm>
-            <a:off x="1051560" y="5093208"/>
-            <a:ext cx="3694176" cy="548640"/>
+              <a:t>제조원가율 = 제조원가 ÷ 약가 × 100     |     예제: 80원/T ÷ 300원/T × 100 = 26.7%</a:t>
+            </a:r>
+          </a:p>
+        </p:txBody>
+      </p:sp>
+    </p:spTree>
+  </p:cSld>
+  <p:clrMapOvr>
+    <a:masterClrMapping/>
+  </p:clrMapOvr>
+</p:sld>
+</file>
+
+<file path=ppt/slides/slide4.xml><?xml version="1.0" encoding="utf-8"?>
+<p:sld xmlns:a="http://schemas.openxmlformats.org/drawingml/2006/main" xmlns:p="http://schemas.openxmlformats.org/presentationml/2006/main" xmlns:r="http://schemas.openxmlformats.org/officeDocument/2006/relationships">
+  <p:cSld>
+    <p:bg>
+      <p:bgPr>
+        <a:solidFill>
+          <a:srgbClr val="F4F8F9"/>
+        </a:solidFill>
+        <a:effectLst/>
+      </p:bgPr>
+    </p:bg>
+    <p:spTree>
+      <p:nvGrpSpPr>
+        <p:cNvPr id="1" name=""/>
+        <p:cNvGrpSpPr/>
+        <p:nvPr/>
+      </p:nvGrpSpPr>
+      <p:grpSpPr/>
+      <p:sp>
+        <p:nvSpPr>
+          <p:cNvPr id="2" name="Rectangle 1"/>
+          <p:cNvSpPr/>
+          <p:nvPr/>
+        </p:nvSpPr>
+        <p:spPr>
+          <a:xfrm>
+            <a:off x="0" y="0"/>
+            <a:ext cx="12191695" cy="59436"/>
           </a:xfrm>
           <a:prstGeom prst="rect">
             <a:avLst/>
-          </a:prstGeom>
-          <a:noFill/>
-        </p:spPr>
-        <p:txBody>
-          <a:bodyPr wrap="square" lIns="0" rIns="0" tIns="0" bIns="0">
-            <a:spAutoFit/>
-          </a:bodyPr>
-          <a:lstStyle/>
-          <a:p>
-            <a:pPr algn="l">
-              <a:lnSpc>
-                <a:spcPct val="116000"/>
-              </a:lnSpc>
-              <a:spcBef>
-                <a:spcPts val="0"/>
-              </a:spcBef>
-              <a:spcAft>
-                <a:spcPts val="100"/>
-              </a:spcAft>
-            </a:pPr>
-            <a:r>
-              <a:rPr sz="1290" b="0" lang="ko-KR">
-                <a:solidFill>
-                  <a:srgbClr val="637F8D"/>
-                </a:solidFill>
-                <a:latin typeface="맑은 고딕"/>
-                <a:ea typeface="맑은 고딕"/>
-              </a:rPr>
-              <a:t>사용 체크 → 기간(1~10년) 선택.</a:t>
-            </a:r>
-          </a:p>
-          <a:p>
-            <a:pPr algn="l">
-              <a:lnSpc>
-                <a:spcPct val="116000"/>
-              </a:lnSpc>
-              <a:spcBef>
-                <a:spcPts val="0"/>
-              </a:spcBef>
-              <a:spcAft>
-                <a:spcPts val="100"/>
-              </a:spcAft>
-            </a:pPr>
-            <a:r>
-              <a:rPr sz="1290" b="0" lang="ko-KR">
-                <a:solidFill>
-                  <a:srgbClr val="637F8D"/>
-                </a:solidFill>
-                <a:latin typeface="맑은 고딕"/>
-                <a:ea typeface="맑은 고딕"/>
-              </a:rPr>
-              <a:t>연차별 판매수량(T) 입력 후 이익 확인</a:t>
-            </a:r>
-          </a:p>
-        </p:txBody>
-      </p:sp>
-      <p:sp>
-        <p:nvSpPr>
-          <p:cNvPr id="22" name="TextBox 21"/>
-          <p:cNvSpPr txBox="1"/>
-          <p:nvPr/>
-        </p:nvSpPr>
-        <p:spPr>
-          <a:xfrm>
-            <a:off x="5074920" y="1920240"/>
-            <a:ext cx="6537960" cy="228600"/>
-          </a:xfrm>
-          <a:prstGeom prst="rect">
-            <a:avLst/>
-          </a:prstGeom>
-          <a:noFill/>
-        </p:spPr>
-        <p:txBody>
-          <a:bodyPr wrap="square" lIns="0" rIns="0" tIns="0" bIns="0">
-            <a:spAutoFit/>
-          </a:bodyPr>
-          <a:lstStyle/>
-          <a:p>
-            <a:pPr algn="l">
-              <a:lnSpc>
-                <a:spcPct val="116000"/>
-              </a:lnSpc>
-              <a:spcBef>
-                <a:spcPts val="0"/>
-              </a:spcBef>
-              <a:spcAft>
-                <a:spcPts val="100"/>
-              </a:spcAft>
-            </a:pPr>
-            <a:r>
-              <a:rPr sz="1300" b="1" lang="ko-KR">
-                <a:solidFill>
-                  <a:srgbClr val="153C4D"/>
-                </a:solidFill>
-                <a:latin typeface="맑은 고딕"/>
-                <a:ea typeface="맑은 고딕"/>
-              </a:rPr>
-              <a:t>연차별 이익과 누적 이익을 시나리오별로 비교</a:t>
-            </a:r>
-          </a:p>
-        </p:txBody>
-      </p:sp>
-      <p:sp>
-        <p:nvSpPr>
-          <p:cNvPr id="23" name="Rounded Rectangle 22"/>
-          <p:cNvSpPr/>
-          <p:nvPr/>
-        </p:nvSpPr>
-        <p:spPr>
-          <a:xfrm>
-            <a:off x="5084064" y="2295144"/>
-            <a:ext cx="82296" cy="82296"/>
-          </a:xfrm>
-          <a:prstGeom prst="roundRect">
-            <a:avLst>
-              <a:gd name="adj" fmla="val 12000"/>
-            </a:avLst>
           </a:prstGeom>
           <a:solidFill>
             <a:srgbClr val="087F82"/>
@@ -6131,14 +6346,14 @@
       </p:sp>
       <p:sp>
         <p:nvSpPr>
-          <p:cNvPr id="24" name="TextBox 23"/>
+          <p:cNvPr id="3" name="TextBox 2"/>
           <p:cNvSpPr txBox="1"/>
           <p:nvPr/>
         </p:nvSpPr>
         <p:spPr>
           <a:xfrm>
-            <a:off x="5230368" y="2240280"/>
-            <a:ext cx="1051560" cy="201168"/>
+            <a:off x="566928" y="338328"/>
+            <a:ext cx="7315200" cy="182880"/>
           </a:xfrm>
           <a:prstGeom prst="rect">
             <a:avLst/>
@@ -6163,28 +6378,259 @@
               </a:spcAft>
             </a:pPr>
             <a:r>
-              <a:rPr sz="1080" b="0" lang="ko-KR">
-                <a:solidFill>
-                  <a:srgbClr val="637F8D"/>
+              <a:rPr sz="1050" b="1" lang="ko-KR">
+                <a:solidFill>
+                  <a:srgbClr val="087F82"/>
                 </a:solidFill>
                 <a:latin typeface="맑은 고딕"/>
                 <a:ea typeface="맑은 고딕"/>
               </a:rPr>
-              <a:t>기본안</a:t>
-            </a:r>
-          </a:p>
-        </p:txBody>
-      </p:sp>
-      <p:sp>
-        <p:nvSpPr>
-          <p:cNvPr id="25" name="Rounded Rectangle 24"/>
+              <a:t>04  SCENARIO COMPARISON</a:t>
+            </a:r>
+          </a:p>
+        </p:txBody>
+      </p:sp>
+      <p:sp>
+        <p:nvSpPr>
+          <p:cNvPr id="4" name="TextBox 3"/>
+          <p:cNvSpPr txBox="1"/>
+          <p:nvPr/>
+        </p:nvSpPr>
+        <p:spPr>
+          <a:xfrm>
+            <a:off x="10744200" y="338328"/>
+            <a:ext cx="877824" cy="182880"/>
+          </a:xfrm>
+          <a:prstGeom prst="rect">
+            <a:avLst/>
+          </a:prstGeom>
+          <a:noFill/>
+        </p:spPr>
+        <p:txBody>
+          <a:bodyPr wrap="square" lIns="0" rIns="0" tIns="0" bIns="0">
+            <a:spAutoFit/>
+          </a:bodyPr>
+          <a:lstStyle/>
+          <a:p>
+            <a:pPr algn="r">
+              <a:lnSpc>
+                <a:spcPct val="116000"/>
+              </a:lnSpc>
+              <a:spcBef>
+                <a:spcPts val="0"/>
+              </a:spcBef>
+              <a:spcAft>
+                <a:spcPts val="100"/>
+              </a:spcAft>
+            </a:pPr>
+            <a:r>
+              <a:rPr sz="1000" b="0" lang="ko-KR">
+                <a:solidFill>
+                  <a:srgbClr val="637F8D"/>
+                </a:solidFill>
+                <a:latin typeface="맑은 고딕"/>
+                <a:ea typeface="맑은 고딕"/>
+              </a:rPr>
+              <a:t>2026.10</a:t>
+            </a:r>
+          </a:p>
+        </p:txBody>
+      </p:sp>
+      <p:sp>
+        <p:nvSpPr>
+          <p:cNvPr id="5" name="TextBox 4"/>
+          <p:cNvSpPr txBox="1"/>
+          <p:nvPr/>
+        </p:nvSpPr>
+        <p:spPr>
+          <a:xfrm>
+            <a:off x="566928" y="694944"/>
+            <a:ext cx="11064240" cy="484632"/>
+          </a:xfrm>
+          <a:prstGeom prst="rect">
+            <a:avLst/>
+          </a:prstGeom>
+          <a:noFill/>
+        </p:spPr>
+        <p:txBody>
+          <a:bodyPr wrap="square" lIns="0" rIns="0" tIns="0" bIns="0">
+            <a:spAutoFit/>
+          </a:bodyPr>
+          <a:lstStyle/>
+          <a:p>
+            <a:pPr algn="l">
+              <a:lnSpc>
+                <a:spcPct val="116000"/>
+              </a:lnSpc>
+              <a:spcBef>
+                <a:spcPts val="0"/>
+              </a:spcBef>
+              <a:spcAft>
+                <a:spcPts val="100"/>
+              </a:spcAft>
+            </a:pPr>
+            <a:r>
+              <a:rPr sz="2900" b="1" lang="ko-KR">
+                <a:solidFill>
+                  <a:srgbClr val="153C4D"/>
+                </a:solidFill>
+                <a:latin typeface="맑은 고딕"/>
+                <a:ea typeface="맑은 고딕"/>
+              </a:rPr>
+              <a:t>조건을 복제해 나란히 비교합니다</a:t>
+            </a:r>
+          </a:p>
+        </p:txBody>
+      </p:sp>
+      <p:sp>
+        <p:nvSpPr>
+          <p:cNvPr id="6" name="TextBox 5"/>
+          <p:cNvSpPr txBox="1"/>
+          <p:nvPr/>
+        </p:nvSpPr>
+        <p:spPr>
+          <a:xfrm>
+            <a:off x="585216" y="1271016"/>
+            <a:ext cx="10972800" cy="329184"/>
+          </a:xfrm>
+          <a:prstGeom prst="rect">
+            <a:avLst/>
+          </a:prstGeom>
+          <a:noFill/>
+        </p:spPr>
+        <p:txBody>
+          <a:bodyPr wrap="square" lIns="0" rIns="0" tIns="0" bIns="0">
+            <a:spAutoFit/>
+          </a:bodyPr>
+          <a:lstStyle/>
+          <a:p>
+            <a:pPr algn="l">
+              <a:lnSpc>
+                <a:spcPct val="116000"/>
+              </a:lnSpc>
+              <a:spcBef>
+                <a:spcPts val="0"/>
+              </a:spcBef>
+              <a:spcAft>
+                <a:spcPts val="100"/>
+              </a:spcAft>
+            </a:pPr>
+            <a:r>
+              <a:rPr sz="1610" b="0" lang="ko-KR">
+                <a:solidFill>
+                  <a:srgbClr val="637F8D"/>
+                </a:solidFill>
+                <a:latin typeface="맑은 고딕"/>
+                <a:ea typeface="맑은 고딕"/>
+              </a:rPr>
+              <a:t>공급처·원료단가·수율·약가 등의 조건을 바꾸어 최대 4개 시나리오를 비교할 수 있습니다.</a:t>
+            </a:r>
+          </a:p>
+        </p:txBody>
+      </p:sp>
+      <p:sp>
+        <p:nvSpPr>
+          <p:cNvPr id="7" name="TextBox 6"/>
+          <p:cNvSpPr txBox="1"/>
+          <p:nvPr/>
+        </p:nvSpPr>
+        <p:spPr>
+          <a:xfrm>
+            <a:off x="566928" y="6565392"/>
+            <a:ext cx="4937760" cy="164592"/>
+          </a:xfrm>
+          <a:prstGeom prst="rect">
+            <a:avLst/>
+          </a:prstGeom>
+          <a:noFill/>
+        </p:spPr>
+        <p:txBody>
+          <a:bodyPr wrap="square" lIns="0" rIns="0" tIns="0" bIns="0">
+            <a:spAutoFit/>
+          </a:bodyPr>
+          <a:lstStyle/>
+          <a:p>
+            <a:pPr algn="l">
+              <a:lnSpc>
+                <a:spcPct val="116000"/>
+              </a:lnSpc>
+              <a:spcBef>
+                <a:spcPts val="0"/>
+              </a:spcBef>
+              <a:spcAft>
+                <a:spcPts val="100"/>
+              </a:spcAft>
+            </a:pPr>
+            <a:r>
+              <a:rPr sz="919" b="0" lang="ko-KR">
+                <a:solidFill>
+                  <a:srgbClr val="087F82"/>
+                </a:solidFill>
+                <a:latin typeface="맑은 고딕"/>
+                <a:ea typeface="맑은 고딕"/>
+                <a:hlinkClick r:id="rId2"/>
+              </a:rPr>
+              <a:t>https://smoothsea45.github.io/project1/</a:t>
+            </a:r>
+          </a:p>
+        </p:txBody>
+      </p:sp>
+      <p:sp>
+        <p:nvSpPr>
+          <p:cNvPr id="8" name="TextBox 7"/>
+          <p:cNvSpPr txBox="1"/>
+          <p:nvPr/>
+        </p:nvSpPr>
+        <p:spPr>
+          <a:xfrm>
+            <a:off x="11064240" y="6565392"/>
+            <a:ext cx="548640" cy="164592"/>
+          </a:xfrm>
+          <a:prstGeom prst="rect">
+            <a:avLst/>
+          </a:prstGeom>
+          <a:noFill/>
+        </p:spPr>
+        <p:txBody>
+          <a:bodyPr wrap="square" lIns="0" rIns="0" tIns="0" bIns="0">
+            <a:spAutoFit/>
+          </a:bodyPr>
+          <a:lstStyle/>
+          <a:p>
+            <a:pPr algn="r">
+              <a:lnSpc>
+                <a:spcPct val="116000"/>
+              </a:lnSpc>
+              <a:spcBef>
+                <a:spcPts val="0"/>
+              </a:spcBef>
+              <a:spcAft>
+                <a:spcPts val="100"/>
+              </a:spcAft>
+            </a:pPr>
+            <a:r>
+              <a:rPr sz="919" b="0" lang="ko-KR">
+                <a:solidFill>
+                  <a:srgbClr val="637F8D"/>
+                </a:solidFill>
+                <a:latin typeface="맑은 고딕"/>
+                <a:ea typeface="맑은 고딕"/>
+              </a:rPr>
+              <a:t>04 / 05</a:t>
+            </a:r>
+          </a:p>
+        </p:txBody>
+      </p:sp>
+      <p:sp>
+        <p:nvSpPr>
+          <p:cNvPr id="9" name="Rounded Rectangle 8"/>
           <p:cNvSpPr/>
           <p:nvPr/>
         </p:nvSpPr>
         <p:spPr>
           <a:xfrm>
-            <a:off x="6236208" y="2295144"/>
-            <a:ext cx="82296" cy="82296"/>
+            <a:off x="566928" y="1783080"/>
+            <a:ext cx="2002536" cy="292608"/>
           </a:xfrm>
           <a:prstGeom prst="roundRect">
             <a:avLst>
@@ -6192,7 +6638,7 @@
             </a:avLst>
           </a:prstGeom>
           <a:solidFill>
-            <a:srgbClr val="8B5CA9"/>
+            <a:srgbClr val="E7F4F2"/>
           </a:solidFill>
           <a:ln>
             <a:noFill/>
@@ -6222,14 +6668,14 @@
       </p:sp>
       <p:sp>
         <p:nvSpPr>
-          <p:cNvPr id="26" name="TextBox 25"/>
+          <p:cNvPr id="10" name="TextBox 9"/>
           <p:cNvSpPr txBox="1"/>
           <p:nvPr/>
         </p:nvSpPr>
         <p:spPr>
           <a:xfrm>
-            <a:off x="6382512" y="2240280"/>
-            <a:ext cx="2103120" cy="201168"/>
+            <a:off x="658368" y="1824228"/>
+            <a:ext cx="1819656" cy="182880"/>
           </a:xfrm>
           <a:prstGeom prst="rect">
             <a:avLst/>
@@ -6254,87 +6700,61 @@
               </a:spcAft>
             </a:pPr>
             <a:r>
-              <a:rPr sz="1080" b="0" lang="ko-KR">
-                <a:solidFill>
-                  <a:srgbClr val="637F8D"/>
+              <a:rPr sz="1030" b="1" lang="ko-KR">
+                <a:solidFill>
+                  <a:srgbClr val="087F82"/>
                 </a:solidFill>
                 <a:latin typeface="맑은 고딕"/>
                 <a:ea typeface="맑은 고딕"/>
               </a:rPr>
-              <a:t>API 단가 절감안</a:t>
-            </a:r>
-          </a:p>
-        </p:txBody>
-      </p:sp>
-      <p:sp>
-        <p:nvSpPr>
-          <p:cNvPr id="27" name="TextBox 26"/>
-          <p:cNvSpPr txBox="1"/>
-          <p:nvPr/>
-        </p:nvSpPr>
-        <p:spPr>
-          <a:xfrm>
-            <a:off x="9445752" y="2249424"/>
-            <a:ext cx="2157984" cy="201168"/>
+              <a:t>실제 비교표 · 상단 발췌</a:t>
+            </a:r>
+          </a:p>
+        </p:txBody>
+      </p:sp>
+      <p:pic>
+        <p:nvPicPr>
+          <p:cNvPr id="11" name="Picture 10" descr="comparison.png"/>
+          <p:cNvPicPr>
+            <a:picLocks noChangeAspect="1"/>
+          </p:cNvPicPr>
+          <p:nvPr/>
+        </p:nvPicPr>
+        <p:blipFill>
+          <a:blip r:embed="rId3"/>
+          <a:stretch>
+            <a:fillRect/>
+          </a:stretch>
+        </p:blipFill>
+        <p:spPr>
+          <a:xfrm>
+            <a:off x="566928" y="2194560"/>
+            <a:ext cx="7287768" cy="3824786"/>
           </a:xfrm>
           <a:prstGeom prst="rect">
             <a:avLst/>
           </a:prstGeom>
-          <a:noFill/>
-        </p:spPr>
-        <p:txBody>
-          <a:bodyPr wrap="square" lIns="0" rIns="0" tIns="0" bIns="0">
-            <a:spAutoFit/>
-          </a:bodyPr>
-          <a:lstStyle/>
-          <a:p>
-            <a:pPr algn="r">
-              <a:lnSpc>
-                <a:spcPct val="116000"/>
-              </a:lnSpc>
-              <a:spcBef>
-                <a:spcPts val="0"/>
-              </a:spcBef>
-              <a:spcAft>
-                <a:spcPts val="100"/>
-              </a:spcAft>
-            </a:pPr>
-            <a:r>
-              <a:rPr sz="1019" b="0" lang="ko-KR">
-                <a:solidFill>
-                  <a:srgbClr val="637F8D"/>
-                </a:solidFill>
-                <a:latin typeface="맑은 고딕"/>
-                <a:ea typeface="맑은 고딕"/>
-              </a:rPr>
-              <a:t>가상 예제 화면</a:t>
-            </a:r>
-          </a:p>
-        </p:txBody>
-      </p:sp>
-      <p:sp>
-        <p:nvSpPr>
-          <p:cNvPr id="28" name="Rounded Rectangle 27"/>
+        </p:spPr>
+      </p:pic>
+      <p:sp>
+        <p:nvSpPr>
+          <p:cNvPr id="12" name="Oval 11"/>
           <p:cNvSpPr/>
           <p:nvPr/>
         </p:nvSpPr>
         <p:spPr>
           <a:xfrm>
-            <a:off x="5010912" y="2569464"/>
-            <a:ext cx="6611112" cy="2029968"/>
-          </a:xfrm>
-          <a:prstGeom prst="roundRect">
-            <a:avLst>
-              <a:gd name="adj" fmla="val 12000"/>
-            </a:avLst>
+            <a:off x="8257031" y="2240280"/>
+            <a:ext cx="320040" cy="320040"/>
+          </a:xfrm>
+          <a:prstGeom prst="ellipse">
+            <a:avLst/>
           </a:prstGeom>
           <a:solidFill>
-            <a:srgbClr val="FFFFFF"/>
+            <a:srgbClr val="E7F4F2"/>
           </a:solidFill>
-          <a:ln w="8890">
-            <a:solidFill>
-              <a:srgbClr val="D9E5E8"/>
-            </a:solidFill>
+          <a:ln>
+            <a:noFill/>
           </a:ln>
         </p:spPr>
         <p:style>
@@ -6352,52 +6772,150 @@
           </a:fontRef>
         </p:style>
         <p:txBody>
-          <a:bodyPr rtlCol="0" anchor="ctr"/>
+          <a:bodyPr rtlCol="0" anchor="ctr" lIns="0" rIns="0" tIns="0" bIns="0"/>
           <a:lstStyle/>
           <a:p>
             <a:pPr algn="ctr"/>
-          </a:p>
-        </p:txBody>
-      </p:sp>
-      <p:pic>
-        <p:nvPicPr>
-          <p:cNvPr id="29" name="Picture 28" descr="profit.png"/>
-          <p:cNvPicPr>
-            <a:picLocks noChangeAspect="1"/>
-          </p:cNvPicPr>
-          <p:nvPr/>
-        </p:nvPicPr>
-        <p:blipFill>
-          <a:blip r:embed="rId3"/>
-          <a:stretch>
-            <a:fillRect/>
-          </a:stretch>
-        </p:blipFill>
-        <p:spPr>
-          <a:xfrm>
-            <a:off x="5074920" y="2615184"/>
-            <a:ext cx="6483096" cy="1933141"/>
+            <a:r>
+              <a:rPr sz="1100" b="1">
+                <a:solidFill>
+                  <a:srgbClr val="087F82"/>
+                </a:solidFill>
+                <a:latin typeface="맑은 고딕"/>
+              </a:rPr>
+              <a:t>01</a:t>
+            </a:r>
+          </a:p>
+        </p:txBody>
+      </p:sp>
+      <p:sp>
+        <p:nvSpPr>
+          <p:cNvPr id="13" name="TextBox 12"/>
+          <p:cNvSpPr txBox="1"/>
+          <p:nvPr/>
+        </p:nvSpPr>
+        <p:spPr>
+          <a:xfrm>
+            <a:off x="8686800" y="2226564"/>
+            <a:ext cx="2907791" cy="301752"/>
           </a:xfrm>
           <a:prstGeom prst="rect">
             <a:avLst/>
           </a:prstGeom>
-        </p:spPr>
-      </p:pic>
-      <p:sp>
-        <p:nvSpPr>
-          <p:cNvPr id="30" name="Rounded Rectangle 29"/>
+          <a:noFill/>
+        </p:spPr>
+        <p:txBody>
+          <a:bodyPr wrap="square" lIns="0" rIns="0" tIns="0" bIns="0">
+            <a:spAutoFit/>
+          </a:bodyPr>
+          <a:lstStyle/>
+          <a:p>
+            <a:pPr algn="l">
+              <a:lnSpc>
+                <a:spcPct val="116000"/>
+              </a:lnSpc>
+              <a:spcBef>
+                <a:spcPts val="0"/>
+              </a:spcBef>
+              <a:spcAft>
+                <a:spcPts val="100"/>
+              </a:spcAft>
+            </a:pPr>
+            <a:r>
+              <a:rPr sz="1520" b="1" lang="ko-KR">
+                <a:solidFill>
+                  <a:srgbClr val="153C4D"/>
+                </a:solidFill>
+                <a:latin typeface="맑은 고딕"/>
+                <a:ea typeface="맑은 고딕"/>
+              </a:rPr>
+              <a:t>현재 입력 복제</a:t>
+            </a:r>
+          </a:p>
+        </p:txBody>
+      </p:sp>
+      <p:sp>
+        <p:nvSpPr>
+          <p:cNvPr id="14" name="TextBox 13"/>
+          <p:cNvSpPr txBox="1"/>
+          <p:nvPr/>
+        </p:nvSpPr>
+        <p:spPr>
+          <a:xfrm>
+            <a:off x="8686800" y="2596896"/>
+            <a:ext cx="2907791" cy="640080"/>
+          </a:xfrm>
+          <a:prstGeom prst="rect">
+            <a:avLst/>
+          </a:prstGeom>
+          <a:noFill/>
+        </p:spPr>
+        <p:txBody>
+          <a:bodyPr wrap="square" lIns="0" rIns="0" tIns="0" bIns="0">
+            <a:spAutoFit/>
+          </a:bodyPr>
+          <a:lstStyle/>
+          <a:p>
+            <a:pPr algn="l">
+              <a:lnSpc>
+                <a:spcPct val="116000"/>
+              </a:lnSpc>
+              <a:spcBef>
+                <a:spcPts val="0"/>
+              </a:spcBef>
+              <a:spcAft>
+                <a:spcPts val="100"/>
+              </a:spcAft>
+            </a:pPr>
+            <a:r>
+              <a:rPr sz="1250" b="0" lang="ko-KR">
+                <a:solidFill>
+                  <a:srgbClr val="637F8D"/>
+                </a:solidFill>
+                <a:latin typeface="맑은 고딕"/>
+                <a:ea typeface="맑은 고딕"/>
+              </a:rPr>
+              <a:t>복제한 조건을 수정해도</a:t>
+            </a:r>
+          </a:p>
+          <a:p>
+            <a:pPr algn="l">
+              <a:lnSpc>
+                <a:spcPct val="116000"/>
+              </a:lnSpc>
+              <a:spcBef>
+                <a:spcPts val="0"/>
+              </a:spcBef>
+              <a:spcAft>
+                <a:spcPts val="100"/>
+              </a:spcAft>
+            </a:pPr>
+            <a:r>
+              <a:rPr sz="1250" b="0" lang="ko-KR">
+                <a:solidFill>
+                  <a:srgbClr val="637F8D"/>
+                </a:solidFill>
+                <a:latin typeface="맑은 고딕"/>
+                <a:ea typeface="맑은 고딕"/>
+              </a:rPr>
+              <a:t>원본 시나리오는 유지됩니다.</a:t>
+            </a:r>
+          </a:p>
+        </p:txBody>
+      </p:sp>
+      <p:sp>
+        <p:nvSpPr>
+          <p:cNvPr id="15" name="Oval 14"/>
           <p:cNvSpPr/>
           <p:nvPr/>
         </p:nvSpPr>
         <p:spPr>
           <a:xfrm>
-            <a:off x="5029200" y="4773168"/>
-            <a:ext cx="6592824" cy="758952"/>
-          </a:xfrm>
-          <a:prstGeom prst="roundRect">
-            <a:avLst>
-              <a:gd name="adj" fmla="val 12000"/>
-            </a:avLst>
+            <a:off x="8257031" y="3328416"/>
+            <a:ext cx="320040" cy="320040"/>
+          </a:xfrm>
+          <a:prstGeom prst="ellipse">
+            <a:avLst/>
           </a:prstGeom>
           <a:solidFill>
             <a:srgbClr val="E7F4F2"/>
@@ -6421,23 +6939,32 @@
           </a:fontRef>
         </p:style>
         <p:txBody>
-          <a:bodyPr rtlCol="0" anchor="ctr"/>
+          <a:bodyPr rtlCol="0" anchor="ctr" lIns="0" rIns="0" tIns="0" bIns="0"/>
           <a:lstStyle/>
           <a:p>
             <a:pPr algn="ctr"/>
-          </a:p>
-        </p:txBody>
-      </p:sp>
-      <p:sp>
-        <p:nvSpPr>
-          <p:cNvPr id="31" name="TextBox 30"/>
+            <a:r>
+              <a:rPr sz="1100" b="1">
+                <a:solidFill>
+                  <a:srgbClr val="087F82"/>
+                </a:solidFill>
+                <a:latin typeface="맑은 고딕"/>
+              </a:rPr>
+              <a:t>02</a:t>
+            </a:r>
+          </a:p>
+        </p:txBody>
+      </p:sp>
+      <p:sp>
+        <p:nvSpPr>
+          <p:cNvPr id="16" name="TextBox 15"/>
           <p:cNvSpPr txBox="1"/>
           <p:nvPr/>
         </p:nvSpPr>
         <p:spPr>
           <a:xfrm>
-            <a:off x="5212080" y="4882896"/>
-            <a:ext cx="6217920" cy="246888"/>
+            <a:off x="8686800" y="3314700"/>
+            <a:ext cx="2907791" cy="301752"/>
           </a:xfrm>
           <a:prstGeom prst="rect">
             <a:avLst/>
@@ -6462,28 +6989,28 @@
               </a:spcAft>
             </a:pPr>
             <a:r>
-              <a:rPr sz="1380" b="1" lang="ko-KR">
-                <a:solidFill>
-                  <a:srgbClr val="087F82"/>
+              <a:rPr sz="1520" b="1" lang="ko-KR">
+                <a:solidFill>
+                  <a:srgbClr val="153C4D"/>
                 </a:solidFill>
                 <a:latin typeface="맑은 고딕"/>
                 <a:ea typeface="맑은 고딕"/>
               </a:rPr>
-              <a:t>예상이익 = 판매수량 × (연차별 약가 − 제조원가/T)</a:t>
-            </a:r>
-          </a:p>
-        </p:txBody>
-      </p:sp>
-      <p:sp>
-        <p:nvSpPr>
-          <p:cNvPr id="32" name="TextBox 31"/>
+              <a:t>차이와 연차 확인</a:t>
+            </a:r>
+          </a:p>
+        </p:txBody>
+      </p:sp>
+      <p:sp>
+        <p:nvSpPr>
+          <p:cNvPr id="17" name="TextBox 16"/>
           <p:cNvSpPr txBox="1"/>
           <p:nvPr/>
         </p:nvSpPr>
         <p:spPr>
           <a:xfrm>
-            <a:off x="5212080" y="5230368"/>
-            <a:ext cx="6217920" cy="201168"/>
+            <a:off x="8686800" y="3685032"/>
+            <a:ext cx="2907791" cy="640080"/>
           </a:xfrm>
           <a:prstGeom prst="rect">
             <a:avLst/>
@@ -6508,39 +7035,16 @@
               </a:spcAft>
             </a:pPr>
             <a:r>
-              <a:rPr sz="1150" b="0" lang="ko-KR">
-                <a:solidFill>
-                  <a:srgbClr val="153C4D"/>
+              <a:rPr sz="1250" b="0" lang="ko-KR">
+                <a:solidFill>
+                  <a:srgbClr val="637F8D"/>
                 </a:solidFill>
                 <a:latin typeface="맑은 고딕"/>
                 <a:ea typeface="맑은 고딕"/>
               </a:rPr>
-              <a:t>예: 100,000T × (300원/T − 80원/T) = 22,000,000원</a:t>
-            </a:r>
-          </a:p>
-        </p:txBody>
-      </p:sp>
-      <p:sp>
-        <p:nvSpPr>
-          <p:cNvPr id="33" name="TextBox 32"/>
-          <p:cNvSpPr txBox="1"/>
-          <p:nvPr/>
-        </p:nvSpPr>
-        <p:spPr>
-          <a:xfrm>
-            <a:off x="5084064" y="5605272"/>
-            <a:ext cx="6519672" cy="201168"/>
-          </a:xfrm>
-          <a:prstGeom prst="rect">
-            <a:avLst/>
-          </a:prstGeom>
-          <a:noFill/>
-        </p:spPr>
-        <p:txBody>
-          <a:bodyPr wrap="square" lIns="0" rIns="0" tIns="0" bIns="0">
-            <a:spAutoFit/>
-          </a:bodyPr>
-          <a:lstStyle/>
+              <a:t>조건·원가율·비용 구성을 비교.</a:t>
+            </a:r>
+          </a:p>
           <a:p>
             <a:pPr algn="l">
               <a:lnSpc>
@@ -6554,41 +7058,37 @@
               </a:spcAft>
             </a:pPr>
             <a:r>
-              <a:rPr sz="1050" b="0" lang="ko-KR">
+              <a:rPr sz="1250" b="0" lang="ko-KR">
                 <a:solidFill>
                   <a:srgbClr val="637F8D"/>
                 </a:solidFill>
                 <a:latin typeface="맑은 고딕"/>
                 <a:ea typeface="맑은 고딕"/>
               </a:rPr>
-              <a:t>제조원가만 반영한 예상이익이며, 판관비·개발비·세금은 제외합니다.</a:t>
-            </a:r>
-          </a:p>
-        </p:txBody>
-      </p:sp>
-      <p:sp>
-        <p:nvSpPr>
-          <p:cNvPr id="34" name="Rounded Rectangle 33"/>
+              <a:t>연차를 누르면 도넛도 변경됩니다.</a:t>
+            </a:r>
+          </a:p>
+        </p:txBody>
+      </p:sp>
+      <p:sp>
+        <p:nvSpPr>
+          <p:cNvPr id="18" name="Oval 17"/>
           <p:cNvSpPr/>
           <p:nvPr/>
         </p:nvSpPr>
         <p:spPr>
           <a:xfrm>
-            <a:off x="566928" y="6035040"/>
-            <a:ext cx="11055096" cy="393192"/>
-          </a:xfrm>
-          <a:prstGeom prst="roundRect">
-            <a:avLst>
-              <a:gd name="adj" fmla="val 12000"/>
-            </a:avLst>
+            <a:off x="8257031" y="4416552"/>
+            <a:ext cx="320040" cy="320040"/>
+          </a:xfrm>
+          <a:prstGeom prst="ellipse">
+            <a:avLst/>
           </a:prstGeom>
           <a:solidFill>
-            <a:srgbClr val="FFFFFF"/>
+            <a:srgbClr val="E7F4F2"/>
           </a:solidFill>
-          <a:ln w="8890">
-            <a:solidFill>
-              <a:srgbClr val="D9E5E8"/>
-            </a:solidFill>
+          <a:ln>
+            <a:noFill/>
           </a:ln>
         </p:spPr>
         <p:style>
@@ -6606,23 +7106,32 @@
           </a:fontRef>
         </p:style>
         <p:txBody>
-          <a:bodyPr rtlCol="0" anchor="ctr"/>
+          <a:bodyPr rtlCol="0" anchor="ctr" lIns="0" rIns="0" tIns="0" bIns="0"/>
           <a:lstStyle/>
           <a:p>
             <a:pPr algn="ctr"/>
-          </a:p>
-        </p:txBody>
-      </p:sp>
-      <p:sp>
-        <p:nvSpPr>
-          <p:cNvPr id="35" name="TextBox 34"/>
+            <a:r>
+              <a:rPr sz="1100" b="1">
+                <a:solidFill>
+                  <a:srgbClr val="087F82"/>
+                </a:solidFill>
+                <a:latin typeface="맑은 고딕"/>
+              </a:rPr>
+              <a:t>03</a:t>
+            </a:r>
+          </a:p>
+        </p:txBody>
+      </p:sp>
+      <p:sp>
+        <p:nvSpPr>
+          <p:cNvPr id="19" name="TextBox 18"/>
           <p:cNvSpPr txBox="1"/>
           <p:nvPr/>
         </p:nvSpPr>
         <p:spPr>
           <a:xfrm>
-            <a:off x="740664" y="6126480"/>
-            <a:ext cx="10716768" cy="210312"/>
+            <a:off x="8686800" y="4402836"/>
+            <a:ext cx="2907791" cy="301752"/>
           </a:xfrm>
           <a:prstGeom prst="rect">
             <a:avLst/>
@@ -6647,28 +7156,303 @@
               </a:spcAft>
             </a:pPr>
             <a:r>
-              <a:rPr sz="1300" b="1" lang="ko-KR">
+              <a:rPr sz="1520" b="1" lang="ko-KR">
                 <a:solidFill>
                   <a:srgbClr val="153C4D"/>
                 </a:solidFill>
                 <a:latin typeface="맑은 고딕"/>
                 <a:ea typeface="맑은 고딕"/>
               </a:rPr>
-              <a:t>보관·재사용: ‘프로젝트 저장’(JSON) → ‘파일 열기’     |     비교표는 ‘비교표 출력’으로 인쇄</a:t>
-            </a:r>
-          </a:p>
-        </p:txBody>
-      </p:sp>
-      <p:sp>
-        <p:nvSpPr>
-          <p:cNvPr id="36" name="TextBox 35"/>
+              <a:t>정렬·출력·보관</a:t>
+            </a:r>
+          </a:p>
+        </p:txBody>
+      </p:sp>
+      <p:sp>
+        <p:nvSpPr>
+          <p:cNvPr id="20" name="TextBox 19"/>
           <p:cNvSpPr txBox="1"/>
           <p:nvPr/>
         </p:nvSpPr>
         <p:spPr>
           <a:xfrm>
-            <a:off x="5093208" y="6565392"/>
-            <a:ext cx="5669280" cy="164592"/>
+            <a:off x="8686800" y="4773168"/>
+            <a:ext cx="2907791" cy="640080"/>
+          </a:xfrm>
+          <a:prstGeom prst="rect">
+            <a:avLst/>
+          </a:prstGeom>
+          <a:noFill/>
+        </p:spPr>
+        <p:txBody>
+          <a:bodyPr wrap="square" lIns="0" rIns="0" tIns="0" bIns="0">
+            <a:spAutoFit/>
+          </a:bodyPr>
+          <a:lstStyle/>
+          <a:p>
+            <a:pPr algn="l">
+              <a:lnSpc>
+                <a:spcPct val="116000"/>
+              </a:lnSpc>
+              <a:spcBef>
+                <a:spcPts val="0"/>
+              </a:spcBef>
+              <a:spcAft>
+                <a:spcPts val="100"/>
+              </a:spcAft>
+            </a:pPr>
+            <a:r>
+              <a:rPr sz="1250" b="0" lang="ko-KR">
+                <a:solidFill>
+                  <a:srgbClr val="637F8D"/>
+                </a:solidFill>
+                <a:latin typeface="맑은 고딕"/>
+                <a:ea typeface="맑은 고딕"/>
+              </a:rPr>
+              <a:t>시나리오 탭을 드래그해 정렬.</a:t>
+            </a:r>
+          </a:p>
+          <a:p>
+            <a:pPr algn="l">
+              <a:lnSpc>
+                <a:spcPct val="116000"/>
+              </a:lnSpc>
+              <a:spcBef>
+                <a:spcPts val="0"/>
+              </a:spcBef>
+              <a:spcAft>
+                <a:spcPts val="100"/>
+              </a:spcAft>
+            </a:pPr>
+            <a:r>
+              <a:rPr sz="1250" b="0" lang="ko-KR">
+                <a:solidFill>
+                  <a:srgbClr val="637F8D"/>
+                </a:solidFill>
+                <a:latin typeface="맑은 고딕"/>
+                <a:ea typeface="맑은 고딕"/>
+              </a:rPr>
+              <a:t>비교표 출력으로 인쇄합니다.</a:t>
+            </a:r>
+          </a:p>
+        </p:txBody>
+      </p:sp>
+      <p:sp>
+        <p:nvSpPr>
+          <p:cNvPr id="21" name="Rounded Rectangle 20"/>
+          <p:cNvSpPr/>
+          <p:nvPr/>
+        </p:nvSpPr>
+        <p:spPr>
+          <a:xfrm>
+            <a:off x="566928" y="6135624"/>
+            <a:ext cx="11055096" cy="347472"/>
+          </a:xfrm>
+          <a:prstGeom prst="roundRect">
+            <a:avLst>
+              <a:gd name="adj" fmla="val 12000"/>
+            </a:avLst>
+          </a:prstGeom>
+          <a:solidFill>
+            <a:srgbClr val="153C4D"/>
+          </a:solidFill>
+          <a:ln>
+            <a:noFill/>
+          </a:ln>
+        </p:spPr>
+        <p:style>
+          <a:lnRef idx="1">
+            <a:schemeClr val="accent1"/>
+          </a:lnRef>
+          <a:fillRef idx="3">
+            <a:schemeClr val="accent1"/>
+          </a:fillRef>
+          <a:effectRef idx="2">
+            <a:schemeClr val="accent1"/>
+          </a:effectRef>
+          <a:fontRef idx="minor">
+            <a:schemeClr val="lt1"/>
+          </a:fontRef>
+        </p:style>
+        <p:txBody>
+          <a:bodyPr rtlCol="0" anchor="ctr"/>
+          <a:lstStyle/>
+          <a:p>
+            <a:pPr algn="ctr"/>
+          </a:p>
+        </p:txBody>
+      </p:sp>
+      <p:sp>
+        <p:nvSpPr>
+          <p:cNvPr id="22" name="TextBox 21"/>
+          <p:cNvSpPr txBox="1"/>
+          <p:nvPr/>
+        </p:nvSpPr>
+        <p:spPr>
+          <a:xfrm>
+            <a:off x="749808" y="6190488"/>
+            <a:ext cx="10698480" cy="201168"/>
+          </a:xfrm>
+          <a:prstGeom prst="rect">
+            <a:avLst/>
+          </a:prstGeom>
+          <a:noFill/>
+        </p:spPr>
+        <p:txBody>
+          <a:bodyPr wrap="square" lIns="0" rIns="0" tIns="0" bIns="0">
+            <a:spAutoFit/>
+          </a:bodyPr>
+          <a:lstStyle/>
+          <a:p>
+            <a:pPr algn="l">
+              <a:lnSpc>
+                <a:spcPct val="116000"/>
+              </a:lnSpc>
+              <a:spcBef>
+                <a:spcPts val="0"/>
+              </a:spcBef>
+              <a:spcAft>
+                <a:spcPts val="100"/>
+              </a:spcAft>
+            </a:pPr>
+            <a:r>
+              <a:rPr sz="1300" b="1" lang="ko-KR">
+                <a:solidFill>
+                  <a:srgbClr val="FFFFFF"/>
+                </a:solidFill>
+                <a:latin typeface="맑은 고딕"/>
+                <a:ea typeface="맑은 고딕"/>
+              </a:rPr>
+              <a:t>보관은 ‘프로젝트 저장’(JSON), 다시 사용할 때는 ‘파일 열기’를 선택합니다.</a:t>
+            </a:r>
+          </a:p>
+        </p:txBody>
+      </p:sp>
+    </p:spTree>
+  </p:cSld>
+  <p:clrMapOvr>
+    <a:masterClrMapping/>
+  </p:clrMapOvr>
+</p:sld>
+</file>
+
+<file path=ppt/slides/slide5.xml><?xml version="1.0" encoding="utf-8"?>
+<p:sld xmlns:a="http://schemas.openxmlformats.org/drawingml/2006/main" xmlns:p="http://schemas.openxmlformats.org/presentationml/2006/main" xmlns:r="http://schemas.openxmlformats.org/officeDocument/2006/relationships">
+  <p:cSld>
+    <p:bg>
+      <p:bgPr>
+        <a:solidFill>
+          <a:srgbClr val="F4F8F9"/>
+        </a:solidFill>
+        <a:effectLst/>
+      </p:bgPr>
+    </p:bg>
+    <p:spTree>
+      <p:nvGrpSpPr>
+        <p:cNvPr id="1" name=""/>
+        <p:cNvGrpSpPr/>
+        <p:nvPr/>
+      </p:nvGrpSpPr>
+      <p:grpSpPr/>
+      <p:sp>
+        <p:nvSpPr>
+          <p:cNvPr id="2" name="Rectangle 1"/>
+          <p:cNvSpPr/>
+          <p:nvPr/>
+        </p:nvSpPr>
+        <p:spPr>
+          <a:xfrm>
+            <a:off x="0" y="0"/>
+            <a:ext cx="12191695" cy="59436"/>
+          </a:xfrm>
+          <a:prstGeom prst="rect">
+            <a:avLst/>
+          </a:prstGeom>
+          <a:solidFill>
+            <a:srgbClr val="087F82"/>
+          </a:solidFill>
+          <a:ln>
+            <a:noFill/>
+          </a:ln>
+        </p:spPr>
+        <p:style>
+          <a:lnRef idx="1">
+            <a:schemeClr val="accent1"/>
+          </a:lnRef>
+          <a:fillRef idx="3">
+            <a:schemeClr val="accent1"/>
+          </a:fillRef>
+          <a:effectRef idx="2">
+            <a:schemeClr val="accent1"/>
+          </a:effectRef>
+          <a:fontRef idx="minor">
+            <a:schemeClr val="lt1"/>
+          </a:fontRef>
+        </p:style>
+        <p:txBody>
+          <a:bodyPr rtlCol="0" anchor="ctr"/>
+          <a:lstStyle/>
+          <a:p>
+            <a:pPr algn="ctr"/>
+          </a:p>
+        </p:txBody>
+      </p:sp>
+      <p:sp>
+        <p:nvSpPr>
+          <p:cNvPr id="3" name="TextBox 2"/>
+          <p:cNvSpPr txBox="1"/>
+          <p:nvPr/>
+        </p:nvSpPr>
+        <p:spPr>
+          <a:xfrm>
+            <a:off x="566928" y="338328"/>
+            <a:ext cx="7315200" cy="182880"/>
+          </a:xfrm>
+          <a:prstGeom prst="rect">
+            <a:avLst/>
+          </a:prstGeom>
+          <a:noFill/>
+        </p:spPr>
+        <p:txBody>
+          <a:bodyPr wrap="square" lIns="0" rIns="0" tIns="0" bIns="0">
+            <a:spAutoFit/>
+          </a:bodyPr>
+          <a:lstStyle/>
+          <a:p>
+            <a:pPr algn="l">
+              <a:lnSpc>
+                <a:spcPct val="116000"/>
+              </a:lnSpc>
+              <a:spcBef>
+                <a:spcPts val="0"/>
+              </a:spcBef>
+              <a:spcAft>
+                <a:spcPts val="100"/>
+              </a:spcAft>
+            </a:pPr>
+            <a:r>
+              <a:rPr sz="1050" b="1" lang="ko-KR">
+                <a:solidFill>
+                  <a:srgbClr val="087F82"/>
+                </a:solidFill>
+                <a:latin typeface="맑은 고딕"/>
+                <a:ea typeface="맑은 고딕"/>
+              </a:rPr>
+              <a:t>05  OPTIONAL · SF &amp; PROFIT</a:t>
+            </a:r>
+          </a:p>
+        </p:txBody>
+      </p:sp>
+      <p:sp>
+        <p:nvSpPr>
+          <p:cNvPr id="4" name="TextBox 3"/>
+          <p:cNvSpPr txBox="1"/>
+          <p:nvPr/>
+        </p:nvSpPr>
+        <p:spPr>
+          <a:xfrm>
+            <a:off x="10744200" y="338328"/>
+            <a:ext cx="877824" cy="182880"/>
           </a:xfrm>
           <a:prstGeom prst="rect">
             <a:avLst/>
@@ -6693,14 +7477,563 @@
               </a:spcAft>
             </a:pPr>
             <a:r>
-              <a:rPr sz="860" b="0" lang="ko-KR">
+              <a:rPr sz="1000" b="0" lang="ko-KR">
                 <a:solidFill>
                   <a:srgbClr val="637F8D"/>
                 </a:solidFill>
                 <a:latin typeface="맑은 고딕"/>
                 <a:ea typeface="맑은 고딕"/>
               </a:rPr>
-              <a:t>오프라인 사용: ZIP 전체 폴더 보관 후 web/index.html 실행</a:t>
+              <a:t>2026.10</a:t>
+            </a:r>
+          </a:p>
+        </p:txBody>
+      </p:sp>
+      <p:sp>
+        <p:nvSpPr>
+          <p:cNvPr id="5" name="TextBox 4"/>
+          <p:cNvSpPr txBox="1"/>
+          <p:nvPr/>
+        </p:nvSpPr>
+        <p:spPr>
+          <a:xfrm>
+            <a:off x="566928" y="694944"/>
+            <a:ext cx="11064240" cy="484632"/>
+          </a:xfrm>
+          <a:prstGeom prst="rect">
+            <a:avLst/>
+          </a:prstGeom>
+          <a:noFill/>
+        </p:spPr>
+        <p:txBody>
+          <a:bodyPr wrap="square" lIns="0" rIns="0" tIns="0" bIns="0">
+            <a:spAutoFit/>
+          </a:bodyPr>
+          <a:lstStyle/>
+          <a:p>
+            <a:pPr algn="l">
+              <a:lnSpc>
+                <a:spcPct val="116000"/>
+              </a:lnSpc>
+              <a:spcBef>
+                <a:spcPts val="0"/>
+              </a:spcBef>
+              <a:spcAft>
+                <a:spcPts val="100"/>
+              </a:spcAft>
+            </a:pPr>
+            <a:r>
+              <a:rPr sz="2900" b="1" lang="ko-KR">
+                <a:solidFill>
+                  <a:srgbClr val="153C4D"/>
+                </a:solidFill>
+                <a:latin typeface="맑은 고딕"/>
+                <a:ea typeface="맑은 고딕"/>
+              </a:rPr>
+              <a:t>판매수량을 입력해 연간·누적 이익을 비교합니다</a:t>
+            </a:r>
+          </a:p>
+        </p:txBody>
+      </p:sp>
+      <p:sp>
+        <p:nvSpPr>
+          <p:cNvPr id="6" name="TextBox 5"/>
+          <p:cNvSpPr txBox="1"/>
+          <p:nvPr/>
+        </p:nvSpPr>
+        <p:spPr>
+          <a:xfrm>
+            <a:off x="585216" y="1271016"/>
+            <a:ext cx="10972800" cy="329184"/>
+          </a:xfrm>
+          <a:prstGeom prst="rect">
+            <a:avLst/>
+          </a:prstGeom>
+          <a:noFill/>
+        </p:spPr>
+        <p:txBody>
+          <a:bodyPr wrap="square" lIns="0" rIns="0" tIns="0" bIns="0">
+            <a:spAutoFit/>
+          </a:bodyPr>
+          <a:lstStyle/>
+          <a:p>
+            <a:pPr algn="l">
+              <a:lnSpc>
+                <a:spcPct val="116000"/>
+              </a:lnSpc>
+              <a:spcBef>
+                <a:spcPts val="0"/>
+              </a:spcBef>
+              <a:spcAft>
+                <a:spcPts val="100"/>
+              </a:spcAft>
+            </a:pPr>
+            <a:r>
+              <a:rPr sz="1610" b="0" lang="ko-KR">
+                <a:solidFill>
+                  <a:srgbClr val="637F8D"/>
+                </a:solidFill>
+                <a:latin typeface="맑은 고딕"/>
+                <a:ea typeface="맑은 고딕"/>
+              </a:rPr>
+              <a:t>예상이익 = 연차별 판매수량(T) × (해당 연차 약가 − 현재 제조원가/T)</a:t>
+            </a:r>
+          </a:p>
+        </p:txBody>
+      </p:sp>
+      <p:sp>
+        <p:nvSpPr>
+          <p:cNvPr id="7" name="TextBox 6"/>
+          <p:cNvSpPr txBox="1"/>
+          <p:nvPr/>
+        </p:nvSpPr>
+        <p:spPr>
+          <a:xfrm>
+            <a:off x="566928" y="6565392"/>
+            <a:ext cx="4937760" cy="164592"/>
+          </a:xfrm>
+          <a:prstGeom prst="rect">
+            <a:avLst/>
+          </a:prstGeom>
+          <a:noFill/>
+        </p:spPr>
+        <p:txBody>
+          <a:bodyPr wrap="square" lIns="0" rIns="0" tIns="0" bIns="0">
+            <a:spAutoFit/>
+          </a:bodyPr>
+          <a:lstStyle/>
+          <a:p>
+            <a:pPr algn="l">
+              <a:lnSpc>
+                <a:spcPct val="116000"/>
+              </a:lnSpc>
+              <a:spcBef>
+                <a:spcPts val="0"/>
+              </a:spcBef>
+              <a:spcAft>
+                <a:spcPts val="100"/>
+              </a:spcAft>
+            </a:pPr>
+            <a:r>
+              <a:rPr sz="919" b="0" lang="ko-KR">
+                <a:solidFill>
+                  <a:srgbClr val="087F82"/>
+                </a:solidFill>
+                <a:latin typeface="맑은 고딕"/>
+                <a:ea typeface="맑은 고딕"/>
+                <a:hlinkClick r:id="rId2"/>
+              </a:rPr>
+              <a:t>https://smoothsea45.github.io/project1/</a:t>
+            </a:r>
+          </a:p>
+        </p:txBody>
+      </p:sp>
+      <p:sp>
+        <p:nvSpPr>
+          <p:cNvPr id="8" name="TextBox 7"/>
+          <p:cNvSpPr txBox="1"/>
+          <p:nvPr/>
+        </p:nvSpPr>
+        <p:spPr>
+          <a:xfrm>
+            <a:off x="11064240" y="6565392"/>
+            <a:ext cx="548640" cy="164592"/>
+          </a:xfrm>
+          <a:prstGeom prst="rect">
+            <a:avLst/>
+          </a:prstGeom>
+          <a:noFill/>
+        </p:spPr>
+        <p:txBody>
+          <a:bodyPr wrap="square" lIns="0" rIns="0" tIns="0" bIns="0">
+            <a:spAutoFit/>
+          </a:bodyPr>
+          <a:lstStyle/>
+          <a:p>
+            <a:pPr algn="r">
+              <a:lnSpc>
+                <a:spcPct val="116000"/>
+              </a:lnSpc>
+              <a:spcBef>
+                <a:spcPts val="0"/>
+              </a:spcBef>
+              <a:spcAft>
+                <a:spcPts val="100"/>
+              </a:spcAft>
+            </a:pPr>
+            <a:r>
+              <a:rPr sz="919" b="0" lang="ko-KR">
+                <a:solidFill>
+                  <a:srgbClr val="637F8D"/>
+                </a:solidFill>
+                <a:latin typeface="맑은 고딕"/>
+                <a:ea typeface="맑은 고딕"/>
+              </a:rPr>
+              <a:t>05 / 05</a:t>
+            </a:r>
+          </a:p>
+        </p:txBody>
+      </p:sp>
+      <p:sp>
+        <p:nvSpPr>
+          <p:cNvPr id="9" name="TextBox 8"/>
+          <p:cNvSpPr txBox="1"/>
+          <p:nvPr/>
+        </p:nvSpPr>
+        <p:spPr>
+          <a:xfrm>
+            <a:off x="594360" y="1810512"/>
+            <a:ext cx="8183879" cy="219456"/>
+          </a:xfrm>
+          <a:prstGeom prst="rect">
+            <a:avLst/>
+          </a:prstGeom>
+          <a:noFill/>
+        </p:spPr>
+        <p:txBody>
+          <a:bodyPr wrap="square" lIns="0" rIns="0" tIns="0" bIns="0">
+            <a:spAutoFit/>
+          </a:bodyPr>
+          <a:lstStyle/>
+          <a:p>
+            <a:pPr algn="l">
+              <a:lnSpc>
+                <a:spcPct val="116000"/>
+              </a:lnSpc>
+              <a:spcBef>
+                <a:spcPts val="0"/>
+              </a:spcBef>
+              <a:spcAft>
+                <a:spcPts val="100"/>
+              </a:spcAft>
+            </a:pPr>
+            <a:r>
+              <a:rPr sz="1220" b="1" lang="ko-KR">
+                <a:solidFill>
+                  <a:srgbClr val="087F82"/>
+                </a:solidFill>
+                <a:latin typeface="맑은 고딕"/>
+                <a:ea typeface="맑은 고딕"/>
+              </a:rPr>
+              <a:t>① ‘SF·이익 분석 사용’ 체크 → ② 분석기간(1~10년) 선택 → ③ 연차별 판매수량 입력</a:t>
+            </a:r>
+          </a:p>
+        </p:txBody>
+      </p:sp>
+      <p:pic>
+        <p:nvPicPr>
+          <p:cNvPr id="10" name="Picture 9" descr="sf-table.png"/>
+          <p:cNvPicPr>
+            <a:picLocks noChangeAspect="1"/>
+          </p:cNvPicPr>
+          <p:nvPr/>
+        </p:nvPicPr>
+        <p:blipFill>
+          <a:blip r:embed="rId3"/>
+          <a:stretch>
+            <a:fillRect/>
+          </a:stretch>
+        </p:blipFill>
+        <p:spPr>
+          <a:xfrm>
+            <a:off x="566928" y="2139696"/>
+            <a:ext cx="11055096" cy="815540"/>
+          </a:xfrm>
+          <a:prstGeom prst="rect">
+            <a:avLst/>
+          </a:prstGeom>
+        </p:spPr>
+      </p:pic>
+      <p:sp>
+        <p:nvSpPr>
+          <p:cNvPr id="11" name="Rectangle 10"/>
+          <p:cNvSpPr/>
+          <p:nvPr/>
+        </p:nvSpPr>
+        <p:spPr>
+          <a:xfrm>
+            <a:off x="658368" y="3063240"/>
+            <a:ext cx="91440" cy="91440"/>
+          </a:xfrm>
+          <a:prstGeom prst="rect">
+            <a:avLst/>
+          </a:prstGeom>
+          <a:solidFill>
+            <a:srgbClr val="087F82"/>
+          </a:solidFill>
+          <a:ln>
+            <a:noFill/>
+          </a:ln>
+        </p:spPr>
+        <p:style>
+          <a:lnRef idx="1">
+            <a:schemeClr val="accent1"/>
+          </a:lnRef>
+          <a:fillRef idx="3">
+            <a:schemeClr val="accent1"/>
+          </a:fillRef>
+          <a:effectRef idx="2">
+            <a:schemeClr val="accent1"/>
+          </a:effectRef>
+          <a:fontRef idx="minor">
+            <a:schemeClr val="lt1"/>
+          </a:fontRef>
+        </p:style>
+        <p:txBody>
+          <a:bodyPr rtlCol="0" anchor="ctr"/>
+          <a:lstStyle/>
+          <a:p>
+            <a:pPr algn="ctr"/>
+          </a:p>
+        </p:txBody>
+      </p:sp>
+      <p:sp>
+        <p:nvSpPr>
+          <p:cNvPr id="12" name="TextBox 11"/>
+          <p:cNvSpPr txBox="1"/>
+          <p:nvPr/>
+        </p:nvSpPr>
+        <p:spPr>
+          <a:xfrm>
+            <a:off x="822960" y="3017520"/>
+            <a:ext cx="2039112" cy="201168"/>
+          </a:xfrm>
+          <a:prstGeom prst="rect">
+            <a:avLst/>
+          </a:prstGeom>
+          <a:noFill/>
+        </p:spPr>
+        <p:txBody>
+          <a:bodyPr wrap="square" lIns="0" rIns="0" tIns="0" bIns="0">
+            <a:spAutoFit/>
+          </a:bodyPr>
+          <a:lstStyle/>
+          <a:p>
+            <a:pPr algn="l">
+              <a:lnSpc>
+                <a:spcPct val="116000"/>
+              </a:lnSpc>
+              <a:spcBef>
+                <a:spcPts val="0"/>
+              </a:spcBef>
+              <a:spcAft>
+                <a:spcPts val="100"/>
+              </a:spcAft>
+            </a:pPr>
+            <a:r>
+              <a:rPr sz="1080" b="0" lang="ko-KR">
+                <a:solidFill>
+                  <a:srgbClr val="637F8D"/>
+                </a:solidFill>
+                <a:latin typeface="맑은 고딕"/>
+                <a:ea typeface="맑은 고딕"/>
+              </a:rPr>
+              <a:t>기본안</a:t>
+            </a:r>
+          </a:p>
+        </p:txBody>
+      </p:sp>
+      <p:sp>
+        <p:nvSpPr>
+          <p:cNvPr id="13" name="Rectangle 12"/>
+          <p:cNvSpPr/>
+          <p:nvPr/>
+        </p:nvSpPr>
+        <p:spPr>
+          <a:xfrm>
+            <a:off x="2029968" y="3063240"/>
+            <a:ext cx="91440" cy="91440"/>
+          </a:xfrm>
+          <a:prstGeom prst="rect">
+            <a:avLst/>
+          </a:prstGeom>
+          <a:solidFill>
+            <a:srgbClr val="8B5CA9"/>
+          </a:solidFill>
+          <a:ln>
+            <a:noFill/>
+          </a:ln>
+        </p:spPr>
+        <p:style>
+          <a:lnRef idx="1">
+            <a:schemeClr val="accent1"/>
+          </a:lnRef>
+          <a:fillRef idx="3">
+            <a:schemeClr val="accent1"/>
+          </a:fillRef>
+          <a:effectRef idx="2">
+            <a:schemeClr val="accent1"/>
+          </a:effectRef>
+          <a:fontRef idx="minor">
+            <a:schemeClr val="lt1"/>
+          </a:fontRef>
+        </p:style>
+        <p:txBody>
+          <a:bodyPr rtlCol="0" anchor="ctr"/>
+          <a:lstStyle/>
+          <a:p>
+            <a:pPr algn="ctr"/>
+          </a:p>
+        </p:txBody>
+      </p:sp>
+      <p:sp>
+        <p:nvSpPr>
+          <p:cNvPr id="14" name="TextBox 13"/>
+          <p:cNvSpPr txBox="1"/>
+          <p:nvPr/>
+        </p:nvSpPr>
+        <p:spPr>
+          <a:xfrm>
+            <a:off x="2194560" y="3017520"/>
+            <a:ext cx="2816352" cy="201168"/>
+          </a:xfrm>
+          <a:prstGeom prst="rect">
+            <a:avLst/>
+          </a:prstGeom>
+          <a:noFill/>
+        </p:spPr>
+        <p:txBody>
+          <a:bodyPr wrap="square" lIns="0" rIns="0" tIns="0" bIns="0">
+            <a:spAutoFit/>
+          </a:bodyPr>
+          <a:lstStyle/>
+          <a:p>
+            <a:pPr algn="l">
+              <a:lnSpc>
+                <a:spcPct val="116000"/>
+              </a:lnSpc>
+              <a:spcBef>
+                <a:spcPts val="0"/>
+              </a:spcBef>
+              <a:spcAft>
+                <a:spcPts val="100"/>
+              </a:spcAft>
+            </a:pPr>
+            <a:r>
+              <a:rPr sz="1080" b="0" lang="ko-KR">
+                <a:solidFill>
+                  <a:srgbClr val="637F8D"/>
+                </a:solidFill>
+                <a:latin typeface="맑은 고딕"/>
+                <a:ea typeface="맑은 고딕"/>
+              </a:rPr>
+              <a:t>API 단가 절감안</a:t>
+            </a:r>
+          </a:p>
+        </p:txBody>
+      </p:sp>
+      <p:sp>
+        <p:nvSpPr>
+          <p:cNvPr id="15" name="TextBox 14"/>
+          <p:cNvSpPr txBox="1"/>
+          <p:nvPr/>
+        </p:nvSpPr>
+        <p:spPr>
+          <a:xfrm>
+            <a:off x="7744968" y="3017520"/>
+            <a:ext cx="3803904" cy="201168"/>
+          </a:xfrm>
+          <a:prstGeom prst="rect">
+            <a:avLst/>
+          </a:prstGeom>
+          <a:noFill/>
+        </p:spPr>
+        <p:txBody>
+          <a:bodyPr wrap="square" lIns="0" rIns="0" tIns="0" bIns="0">
+            <a:spAutoFit/>
+          </a:bodyPr>
+          <a:lstStyle/>
+          <a:p>
+            <a:pPr algn="r">
+              <a:lnSpc>
+                <a:spcPct val="116000"/>
+              </a:lnSpc>
+              <a:spcBef>
+                <a:spcPts val="0"/>
+              </a:spcBef>
+              <a:spcAft>
+                <a:spcPts val="100"/>
+              </a:spcAft>
+            </a:pPr>
+            <a:r>
+              <a:rPr sz="1080" b="1" lang="ko-KR">
+                <a:solidFill>
+                  <a:srgbClr val="087F82"/>
+                </a:solidFill>
+                <a:latin typeface="맑은 고딕"/>
+                <a:ea typeface="맑은 고딕"/>
+              </a:rPr>
+              <a:t>④ ‘이익 분석’ 탭에서 시나리오별 비교</a:t>
+            </a:r>
+          </a:p>
+        </p:txBody>
+      </p:sp>
+      <p:pic>
+        <p:nvPicPr>
+          <p:cNvPr id="16" name="Picture 15" descr="profit.png"/>
+          <p:cNvPicPr>
+            <a:picLocks noChangeAspect="1"/>
+          </p:cNvPicPr>
+          <p:nvPr/>
+        </p:nvPicPr>
+        <p:blipFill>
+          <a:blip r:embed="rId4"/>
+          <a:stretch>
+            <a:fillRect/>
+          </a:stretch>
+        </p:blipFill>
+        <p:spPr>
+          <a:xfrm>
+            <a:off x="955547" y="3264408"/>
+            <a:ext cx="10277856" cy="3064670"/>
+          </a:xfrm>
+          <a:prstGeom prst="rect">
+            <a:avLst/>
+          </a:prstGeom>
+        </p:spPr>
+      </p:pic>
+      <p:sp>
+        <p:nvSpPr>
+          <p:cNvPr id="17" name="TextBox 16"/>
+          <p:cNvSpPr txBox="1"/>
+          <p:nvPr/>
+        </p:nvSpPr>
+        <p:spPr>
+          <a:xfrm>
+            <a:off x="594360" y="6373368"/>
+            <a:ext cx="10972800" cy="155448"/>
+          </a:xfrm>
+          <a:prstGeom prst="rect">
+            <a:avLst/>
+          </a:prstGeom>
+          <a:noFill/>
+        </p:spPr>
+        <p:txBody>
+          <a:bodyPr wrap="square" lIns="0" rIns="0" tIns="0" bIns="0">
+            <a:spAutoFit/>
+          </a:bodyPr>
+          <a:lstStyle/>
+          <a:p>
+            <a:pPr algn="l">
+              <a:lnSpc>
+                <a:spcPct val="116000"/>
+              </a:lnSpc>
+              <a:spcBef>
+                <a:spcPts val="0"/>
+              </a:spcBef>
+              <a:spcAft>
+                <a:spcPts val="100"/>
+              </a:spcAft>
+            </a:pPr>
+            <a:r>
+              <a:rPr sz="890" b="0" lang="ko-KR">
+                <a:solidFill>
+                  <a:srgbClr val="637F8D"/>
+                </a:solidFill>
+                <a:latin typeface="맑은 고딕"/>
+                <a:ea typeface="맑은 고딕"/>
+              </a:rPr>
+              <a:t>제조원가/T는 분석기간 동안 일정하게 적용합니다. 예상이익은 판관비·개발비·세금을 제외한 제조원가 기준입니다.</a:t>
             </a:r>
           </a:p>
         </p:txBody>

</xml_diff>